<commit_message>
style: Upgrade presentation to professional corporate design
</commit_message>
<xml_diff>
--- a/Workflow_Presentation.pptx
+++ b/Workflow_Presentation.pptx
@@ -10,8 +10,9 @@
     <p:sldId id="258" r:id="rId9"/>
     <p:sldId id="259" r:id="rId10"/>
     <p:sldId id="260" r:id="rId11"/>
+    <p:sldId id="261" r:id="rId12"/>
   </p:sldIdLst>
-  <p:sldSz cx="9144000" cy="6858000" type="screen4x3"/>
+  <p:sldSz cx="12191695" cy="6858000" type="screen4x3"/>
   <p:notesSz cx="6858000" cy="9144000"/>
   <p:defaultTextStyle>
     <a:defPPr>
@@ -3085,6 +3086,14 @@
 <file path=ppt/slides/slide1.xml><?xml version="1.0" encoding="utf-8"?>
 <p:sld xmlns:a="http://schemas.openxmlformats.org/drawingml/2006/main" xmlns:p="http://schemas.openxmlformats.org/presentationml/2006/main" xmlns:r="http://schemas.openxmlformats.org/officeDocument/2006/relationships">
   <p:cSld>
+    <p:bg>
+      <p:bgPr>
+        <a:solidFill>
+          <a:srgbClr val="0C2340"/>
+        </a:solidFill>
+        <a:effectLst/>
+      </p:bgPr>
+    </p:bg>
     <p:spTree>
       <p:nvGrpSpPr>
         <p:cNvPr id="1" name=""/>
@@ -3094,24 +3103,83 @@
       <p:grpSpPr/>
       <p:sp>
         <p:nvSpPr>
-          <p:cNvPr id="2" name="Title 1"/>
-          <p:cNvSpPr>
-            <a:spLocks noGrp="1"/>
-          </p:cNvSpPr>
-          <p:nvPr>
-            <p:ph type="ctrTitle"/>
-          </p:nvPr>
-        </p:nvSpPr>
-        <p:spPr/>
-        <p:txBody>
-          <a:bodyPr/>
-          <a:lstStyle/>
-          <a:p>
+          <p:cNvPr id="2" name="Rectangle 1"/>
+          <p:cNvSpPr/>
+          <p:nvPr/>
+        </p:nvSpPr>
+        <p:spPr>
+          <a:xfrm>
+            <a:off x="0" y="3200400"/>
+            <a:ext cx="12191695" cy="91440"/>
+          </a:xfrm>
+          <a:prstGeom prst="rect">
+            <a:avLst/>
+          </a:prstGeom>
+          <a:solidFill>
+            <a:srgbClr val="00D2D3"/>
+          </a:solidFill>
+          <a:ln>
+            <a:solidFill>
+              <a:srgbClr val="00D2D3"/>
+            </a:solidFill>
+          </a:ln>
+        </p:spPr>
+        <p:style>
+          <a:lnRef idx="1">
+            <a:schemeClr val="accent1"/>
+          </a:lnRef>
+          <a:fillRef idx="3">
+            <a:schemeClr val="accent1"/>
+          </a:fillRef>
+          <a:effectRef idx="2">
+            <a:schemeClr val="accent1"/>
+          </a:effectRef>
+          <a:fontRef idx="minor">
+            <a:schemeClr val="lt1"/>
+          </a:fontRef>
+        </p:style>
+        <p:txBody>
+          <a:bodyPr rtlCol="0" anchor="ctr"/>
+          <a:lstStyle/>
+          <a:p>
+            <a:pPr algn="ctr"/>
+          </a:p>
+        </p:txBody>
+      </p:sp>
+      <p:sp>
+        <p:nvSpPr>
+          <p:cNvPr id="3" name="TextBox 2"/>
+          <p:cNvSpPr txBox="1"/>
+          <p:nvPr/>
+        </p:nvSpPr>
+        <p:spPr>
+          <a:xfrm>
+            <a:off x="914400" y="1645920"/>
+            <a:ext cx="10058400" cy="1371600"/>
+          </a:xfrm>
+          <a:prstGeom prst="rect">
+            <a:avLst/>
+          </a:prstGeom>
+          <a:noFill/>
+        </p:spPr>
+        <p:txBody>
+          <a:bodyPr wrap="square">
+            <a:spAutoFit/>
+          </a:bodyPr>
+          <a:lstStyle/>
+          <a:p>
+            <a:pPr algn="ctr">
+              <a:defRPr sz="4400" b="1">
+                <a:solidFill>
+                  <a:srgbClr val="FFFFFF"/>
+                </a:solidFill>
+                <a:latin typeface="Segoe UI"/>
+              </a:defRPr>
+            </a:pPr>
             <a:r>
               <a:t>Commercial Fleet Operations &amp;</a:t>
             </a:r>
-          </a:p>
-          <a:p>
+            <a:br/>
             <a:r>
               <a:t>Turnaround Optimization Model</a:t>
             </a:r>
@@ -3120,26 +3188,72 @@
       </p:sp>
       <p:sp>
         <p:nvSpPr>
-          <p:cNvPr id="3" name="Subtitle 2"/>
-          <p:cNvSpPr>
-            <a:spLocks noGrp="1"/>
-          </p:cNvSpPr>
-          <p:nvPr>
-            <p:ph type="subTitle" idx="1"/>
-          </p:nvPr>
-        </p:nvSpPr>
-        <p:spPr/>
-        <p:txBody>
-          <a:bodyPr/>
-          <a:lstStyle/>
-          <a:p>
-            <a:r>
-              <a:t>End-to-End Workflow &amp; Architecture</a:t>
-            </a:r>
-          </a:p>
-          <a:p>
-            <a:r>
-              <a:t>Predicting Cascading Delays to Save Operational Costs</a:t>
+          <p:cNvPr id="4" name="TextBox 3"/>
+          <p:cNvSpPr txBox="1"/>
+          <p:nvPr/>
+        </p:nvSpPr>
+        <p:spPr>
+          <a:xfrm>
+            <a:off x="914400" y="3657600"/>
+            <a:ext cx="10058400" cy="914400"/>
+          </a:xfrm>
+          <a:prstGeom prst="rect">
+            <a:avLst/>
+          </a:prstGeom>
+          <a:noFill/>
+        </p:spPr>
+        <p:txBody>
+          <a:bodyPr wrap="square">
+            <a:spAutoFit/>
+          </a:bodyPr>
+          <a:lstStyle/>
+          <a:p>
+            <a:pPr algn="ctr">
+              <a:defRPr sz="2400" b="0">
+                <a:solidFill>
+                  <a:srgbClr val="C8D0D9"/>
+                </a:solidFill>
+                <a:latin typeface="Segoe UI"/>
+              </a:defRPr>
+            </a:pPr>
+            <a:r>
+              <a:t>Predicting Cascading Delays to Maximize Aircraft Utilization and Reduce Operational Costs</a:t>
+            </a:r>
+          </a:p>
+        </p:txBody>
+      </p:sp>
+      <p:sp>
+        <p:nvSpPr>
+          <p:cNvPr id="5" name="TextBox 4"/>
+          <p:cNvSpPr txBox="1"/>
+          <p:nvPr/>
+        </p:nvSpPr>
+        <p:spPr>
+          <a:xfrm>
+            <a:off x="914400" y="5943600"/>
+            <a:ext cx="10058400" cy="457200"/>
+          </a:xfrm>
+          <a:prstGeom prst="rect">
+            <a:avLst/>
+          </a:prstGeom>
+          <a:noFill/>
+        </p:spPr>
+        <p:txBody>
+          <a:bodyPr wrap="square">
+            <a:spAutoFit/>
+          </a:bodyPr>
+          <a:lstStyle/>
+          <a:p>
+            <a:pPr algn="ctr">
+              <a:defRPr sz="1600" b="1">
+                <a:solidFill>
+                  <a:srgbClr val="00D2D3"/>
+                </a:solidFill>
+                <a:latin typeface="Segoe UI"/>
+              </a:defRPr>
+            </a:pPr>
+            <a:r>
+              <a:t>End-to-End Analytics &amp; Machine Learning Pipeline</a:t>
             </a:r>
           </a:p>
         </p:txBody>
@@ -3155,6 +3269,14 @@
 <file path=ppt/slides/slide2.xml><?xml version="1.0" encoding="utf-8"?>
 <p:sld xmlns:a="http://schemas.openxmlformats.org/drawingml/2006/main" xmlns:p="http://schemas.openxmlformats.org/presentationml/2006/main" xmlns:r="http://schemas.openxmlformats.org/officeDocument/2006/relationships">
   <p:cSld>
+    <p:bg>
+      <p:bgPr>
+        <a:solidFill>
+          <a:srgbClr val="0C2340"/>
+        </a:solidFill>
+        <a:effectLst/>
+      </p:bgPr>
+    </p:bg>
     <p:spTree>
       <p:nvGrpSpPr>
         <p:cNvPr id="1" name=""/>
@@ -3164,66 +3286,151 @@
       <p:grpSpPr/>
       <p:sp>
         <p:nvSpPr>
-          <p:cNvPr id="2" name="Title 1"/>
-          <p:cNvSpPr>
-            <a:spLocks noGrp="1"/>
-          </p:cNvSpPr>
-          <p:nvPr>
-            <p:ph type="title"/>
-          </p:nvPr>
-        </p:nvSpPr>
-        <p:spPr/>
-        <p:txBody>
-          <a:bodyPr/>
-          <a:lstStyle/>
-          <a:p>
-            <a:r>
-              <a:t>The Business Problem: Cascading Delays</a:t>
-            </a:r>
-          </a:p>
-        </p:txBody>
-      </p:sp>
-      <p:sp>
-        <p:nvSpPr>
-          <p:cNvPr id="3" name="Content Placeholder 2"/>
-          <p:cNvSpPr>
-            <a:spLocks noGrp="1"/>
-          </p:cNvSpPr>
-          <p:nvPr>
-            <p:ph idx="1"/>
-          </p:nvPr>
-        </p:nvSpPr>
-        <p:spPr/>
-        <p:txBody>
-          <a:bodyPr/>
-          <a:lstStyle/>
-          <a:p>
-            <a:r>
-              <a:t>Airlines operate on incredibly tight turnaround schedules.</a:t>
-            </a:r>
-          </a:p>
-          <a:p>
-            <a:pPr lvl="1"/>
-            <a:r>
-              <a:t>The Turnaround Buffer: The scheduled ground time between arrival and departure.</a:t>
-            </a:r>
-          </a:p>
-          <a:p>
-            <a:pPr lvl="1"/>
-            <a:r>
-              <a:t>The Problem: When an aircraft arrives late, the buffer is breached.</a:t>
-            </a:r>
-          </a:p>
-          <a:p>
-            <a:pPr lvl="1"/>
-            <a:r>
-              <a:t>The Impact: One delay propagates to the next flight (cascading delays).</a:t>
-            </a:r>
-          </a:p>
-          <a:p>
-            <a:pPr lvl="1"/>
-            <a:r>
-              <a:t>The Cost: The FAA estimates each minute of delay costs airlines ~$75.</a:t>
+          <p:cNvPr id="2" name="TextBox 1"/>
+          <p:cNvSpPr txBox="1"/>
+          <p:nvPr/>
+        </p:nvSpPr>
+        <p:spPr>
+          <a:xfrm>
+            <a:off x="731520" y="457200"/>
+            <a:ext cx="9144000" cy="914400"/>
+          </a:xfrm>
+          <a:prstGeom prst="rect">
+            <a:avLst/>
+          </a:prstGeom>
+          <a:noFill/>
+        </p:spPr>
+        <p:txBody>
+          <a:bodyPr wrap="square">
+            <a:spAutoFit/>
+          </a:bodyPr>
+          <a:lstStyle/>
+          <a:p>
+            <a:pPr algn="l">
+              <a:defRPr sz="3600" b="1">
+                <a:solidFill>
+                  <a:srgbClr val="00D2D3"/>
+                </a:solidFill>
+                <a:latin typeface="Segoe UI"/>
+              </a:defRPr>
+            </a:pPr>
+            <a:r>
+              <a:t>The Operational Bottleneck: Cascading Delays</a:t>
+            </a:r>
+          </a:p>
+        </p:txBody>
+      </p:sp>
+      <p:sp>
+        <p:nvSpPr>
+          <p:cNvPr id="3" name="TextBox 2"/>
+          <p:cNvSpPr txBox="1"/>
+          <p:nvPr/>
+        </p:nvSpPr>
+        <p:spPr>
+          <a:xfrm>
+            <a:off x="731520" y="1645920"/>
+            <a:ext cx="10515600" cy="4572000"/>
+          </a:xfrm>
+          <a:prstGeom prst="rect">
+            <a:avLst/>
+          </a:prstGeom>
+          <a:noFill/>
+        </p:spPr>
+        <p:txBody>
+          <a:bodyPr wrap="square">
+            <a:spAutoFit/>
+          </a:bodyPr>
+          <a:lstStyle/>
+          <a:p/>
+          <a:p>
+            <a:pPr>
+              <a:defRPr sz="2400" b="1">
+                <a:solidFill>
+                  <a:srgbClr val="FFFFFF"/>
+                </a:solidFill>
+                <a:latin typeface="Segoe UI"/>
+              </a:defRPr>
+            </a:pPr>
+            <a:r>
+              <a:t>Airlines operate on incredibly tight turnaround schedules to maximize aircraft utilization.</a:t>
+            </a:r>
+          </a:p>
+          <a:p>
+            <a:pPr lvl="1">
+              <a:defRPr sz="2200" b="1">
+                <a:solidFill>
+                  <a:srgbClr val="FDA05B"/>
+                </a:solidFill>
+                <a:latin typeface="Segoe UI"/>
+              </a:defRPr>
+            </a:pPr>
+            <a:r>
+              <a:t>The Turnaround Buffer</a:t>
+            </a:r>
+          </a:p>
+          <a:p>
+            <a:pPr lvl="2">
+              <a:defRPr sz="1800" b="0">
+                <a:solidFill>
+                  <a:srgbClr val="C8D0D9"/>
+                </a:solidFill>
+                <a:latin typeface="Segoe UI"/>
+              </a:defRPr>
+            </a:pPr>
+            <a:r>
+              <a:t>The scheduled ground time allocated for cleaning, fueling, and boarding between an aircraft's arrival and its next departure.</a:t>
+            </a:r>
+          </a:p>
+          <a:p>
+            <a:pPr lvl="1">
+              <a:defRPr sz="2200" b="1">
+                <a:solidFill>
+                  <a:srgbClr val="FDA05B"/>
+                </a:solidFill>
+                <a:latin typeface="Segoe UI"/>
+              </a:defRPr>
+            </a:pPr>
+            <a:r>
+              <a:t>The Domino Effect (Cascading Delays)</a:t>
+            </a:r>
+          </a:p>
+          <a:p>
+            <a:pPr lvl="2">
+              <a:defRPr sz="1800" b="0">
+                <a:solidFill>
+                  <a:srgbClr val="C8D0D9"/>
+                </a:solidFill>
+                <a:latin typeface="Segoe UI"/>
+              </a:defRPr>
+            </a:pPr>
+            <a:r>
+              <a:t>When an aircraft arrives late, or ground operations exceed the buffer, the delay directly propagates to the next flight utilizing that same physical aircraft.</a:t>
+            </a:r>
+          </a:p>
+          <a:p>
+            <a:pPr lvl="1">
+              <a:defRPr sz="2200" b="1">
+                <a:solidFill>
+                  <a:srgbClr val="FDA05B"/>
+                </a:solidFill>
+                <a:latin typeface="Segoe UI"/>
+              </a:defRPr>
+            </a:pPr>
+            <a:r>
+              <a:t>The Financial Hemorrhage</a:t>
+            </a:r>
+          </a:p>
+          <a:p>
+            <a:pPr lvl="2">
+              <a:defRPr sz="1800" b="0">
+                <a:solidFill>
+                  <a:srgbClr val="C8D0D9"/>
+                </a:solidFill>
+                <a:latin typeface="Segoe UI"/>
+              </a:defRPr>
+            </a:pPr>
+            <a:r>
+              <a:t>According to the FAA and Airlines for America, every single minute of delay costs an airline approximately $75 in crew overtime, passenger compensations, and fuel inefficiencies.</a:t>
             </a:r>
           </a:p>
         </p:txBody>
@@ -3239,6 +3446,14 @@
 <file path=ppt/slides/slide3.xml><?xml version="1.0" encoding="utf-8"?>
 <p:sld xmlns:a="http://schemas.openxmlformats.org/drawingml/2006/main" xmlns:p="http://schemas.openxmlformats.org/presentationml/2006/main" xmlns:r="http://schemas.openxmlformats.org/officeDocument/2006/relationships">
   <p:cSld>
+    <p:bg>
+      <p:bgPr>
+        <a:solidFill>
+          <a:srgbClr val="0C2340"/>
+        </a:solidFill>
+        <a:effectLst/>
+      </p:bgPr>
+    </p:bg>
     <p:spTree>
       <p:nvGrpSpPr>
         <p:cNvPr id="1" name=""/>
@@ -3248,78 +3463,402 @@
       <p:grpSpPr/>
       <p:sp>
         <p:nvSpPr>
-          <p:cNvPr id="2" name="Title 1"/>
-          <p:cNvSpPr>
-            <a:spLocks noGrp="1"/>
-          </p:cNvSpPr>
-          <p:nvPr>
-            <p:ph type="title"/>
-          </p:nvPr>
-        </p:nvSpPr>
-        <p:spPr/>
-        <p:txBody>
-          <a:bodyPr/>
-          <a:lstStyle/>
-          <a:p>
-            <a:r>
-              <a:t>Project Workflow Architecture</a:t>
-            </a:r>
-          </a:p>
-        </p:txBody>
-      </p:sp>
-      <p:sp>
-        <p:nvSpPr>
-          <p:cNvPr id="3" name="Content Placeholder 2"/>
-          <p:cNvSpPr>
-            <a:spLocks noGrp="1"/>
-          </p:cNvSpPr>
-          <p:nvPr>
-            <p:ph idx="1"/>
-          </p:nvPr>
-        </p:nvSpPr>
-        <p:spPr/>
-        <p:txBody>
-          <a:bodyPr/>
-          <a:lstStyle/>
-          <a:p>
-            <a:r>
-              <a:t>How the pipeline operates:</a:t>
-            </a:r>
-          </a:p>
-          <a:p>
-            <a:pPr lvl="1"/>
-            <a:r>
-              <a:t>1. Data Ingestion (db_setup.py)</a:t>
-            </a:r>
-          </a:p>
-          <a:p>
-            <a:pPr lvl="2"/>
-            <a:r>
-              <a:t>Reads raw CSV, formats timestamps, cleans data, loads into SQLite.</a:t>
-            </a:r>
-          </a:p>
-          <a:p>
-            <a:pPr lvl="1"/>
-            <a:r>
-              <a:t>2. Analytical Engine (turnaround_analytics.sql)</a:t>
-            </a:r>
-          </a:p>
-          <a:p>
-            <a:pPr lvl="2"/>
-            <a:r>
-              <a:t>Uses Window Functions to track aircraft across flights and calculate ground turnaround.</a:t>
-            </a:r>
-          </a:p>
-          <a:p>
-            <a:pPr lvl="1"/>
-            <a:r>
-              <a:t>3. Predictive Modeling (train_model.py)</a:t>
-            </a:r>
-          </a:p>
-          <a:p>
-            <a:pPr lvl="2"/>
-            <a:r>
-              <a:t>Trains a Random Forest classifier using engineered features to predict buffer breaches.</a:t>
+          <p:cNvPr id="2" name="TextBox 1"/>
+          <p:cNvSpPr txBox="1"/>
+          <p:nvPr/>
+        </p:nvSpPr>
+        <p:spPr>
+          <a:xfrm>
+            <a:off x="731520" y="457200"/>
+            <a:ext cx="9144000" cy="914400"/>
+          </a:xfrm>
+          <a:prstGeom prst="rect">
+            <a:avLst/>
+          </a:prstGeom>
+          <a:noFill/>
+        </p:spPr>
+        <p:txBody>
+          <a:bodyPr wrap="square">
+            <a:spAutoFit/>
+          </a:bodyPr>
+          <a:lstStyle/>
+          <a:p>
+            <a:pPr algn="l">
+              <a:defRPr sz="3600" b="1">
+                <a:solidFill>
+                  <a:srgbClr val="00D2D3"/>
+                </a:solidFill>
+                <a:latin typeface="Segoe UI"/>
+              </a:defRPr>
+            </a:pPr>
+            <a:r>
+              <a:t>Phase 1: Robust Data Ingestion &amp; Engineering</a:t>
+            </a:r>
+          </a:p>
+        </p:txBody>
+      </p:sp>
+      <p:sp>
+        <p:nvSpPr>
+          <p:cNvPr id="3" name="Rounded Rectangle 2"/>
+          <p:cNvSpPr/>
+          <p:nvPr/>
+        </p:nvSpPr>
+        <p:spPr>
+          <a:xfrm>
+            <a:off x="914400" y="2286000"/>
+            <a:ext cx="2926080" cy="2743200"/>
+          </a:xfrm>
+          <a:prstGeom prst="roundRect">
+            <a:avLst/>
+          </a:prstGeom>
+          <a:solidFill>
+            <a:srgbClr val="14325A"/>
+          </a:solidFill>
+          <a:ln>
+            <a:solidFill>
+              <a:srgbClr val="00D2D3"/>
+            </a:solidFill>
+          </a:ln>
+        </p:spPr>
+        <p:style>
+          <a:lnRef idx="1">
+            <a:schemeClr val="accent1"/>
+          </a:lnRef>
+          <a:fillRef idx="3">
+            <a:schemeClr val="accent1"/>
+          </a:fillRef>
+          <a:effectRef idx="2">
+            <a:schemeClr val="accent1"/>
+          </a:effectRef>
+          <a:fontRef idx="minor">
+            <a:schemeClr val="lt1"/>
+          </a:fontRef>
+        </p:style>
+        <p:txBody>
+          <a:bodyPr rtlCol="0" anchor="ctr"/>
+          <a:lstStyle/>
+          <a:p>
+            <a:pPr algn="ctr"/>
+          </a:p>
+        </p:txBody>
+      </p:sp>
+      <p:sp>
+        <p:nvSpPr>
+          <p:cNvPr id="4" name="TextBox 3"/>
+          <p:cNvSpPr txBox="1"/>
+          <p:nvPr/>
+        </p:nvSpPr>
+        <p:spPr>
+          <a:xfrm>
+            <a:off x="1005840" y="2468880"/>
+            <a:ext cx="2743200" cy="457200"/>
+          </a:xfrm>
+          <a:prstGeom prst="rect">
+            <a:avLst/>
+          </a:prstGeom>
+          <a:noFill/>
+        </p:spPr>
+        <p:txBody>
+          <a:bodyPr wrap="square">
+            <a:spAutoFit/>
+          </a:bodyPr>
+          <a:lstStyle/>
+          <a:p>
+            <a:pPr algn="ctr">
+              <a:defRPr sz="2200" b="1">
+                <a:solidFill>
+                  <a:srgbClr val="FDA05B"/>
+                </a:solidFill>
+                <a:latin typeface="Segoe UI"/>
+              </a:defRPr>
+            </a:pPr>
+            <a:r>
+              <a:t>1. Raw Data Parsing</a:t>
+            </a:r>
+          </a:p>
+        </p:txBody>
+      </p:sp>
+      <p:sp>
+        <p:nvSpPr>
+          <p:cNvPr id="5" name="TextBox 4"/>
+          <p:cNvSpPr txBox="1"/>
+          <p:nvPr/>
+        </p:nvSpPr>
+        <p:spPr>
+          <a:xfrm>
+            <a:off x="1005840" y="3200400"/>
+            <a:ext cx="2743200" cy="1371600"/>
+          </a:xfrm>
+          <a:prstGeom prst="rect">
+            <a:avLst/>
+          </a:prstGeom>
+          <a:noFill/>
+        </p:spPr>
+        <p:txBody>
+          <a:bodyPr wrap="square">
+            <a:spAutoFit/>
+          </a:bodyPr>
+          <a:lstStyle/>
+          <a:p>
+            <a:pPr algn="ctr">
+              <a:defRPr sz="1400" b="0">
+                <a:solidFill>
+                  <a:srgbClr val="C8D0D9"/>
+                </a:solidFill>
+                <a:latin typeface="Segoe UI"/>
+              </a:defRPr>
+            </a:pPr>
+            <a:r>
+              <a:t>Scans root directories for CSV/ZIP datasets.</a:t>
+            </a:r>
+            <a:br/>
+            <a:br/>
+            <a:r>
+              <a:t>Cleans missing values and transforms complex float time-series data into standard Python DateTime objects.</a:t>
+            </a:r>
+          </a:p>
+        </p:txBody>
+      </p:sp>
+      <p:sp>
+        <p:nvSpPr>
+          <p:cNvPr id="6" name="Rounded Rectangle 5"/>
+          <p:cNvSpPr/>
+          <p:nvPr/>
+        </p:nvSpPr>
+        <p:spPr>
+          <a:xfrm>
+            <a:off x="4572000" y="2286000"/>
+            <a:ext cx="2926080" cy="2743200"/>
+          </a:xfrm>
+          <a:prstGeom prst="roundRect">
+            <a:avLst/>
+          </a:prstGeom>
+          <a:solidFill>
+            <a:srgbClr val="14325A"/>
+          </a:solidFill>
+          <a:ln>
+            <a:solidFill>
+              <a:srgbClr val="00D2D3"/>
+            </a:solidFill>
+          </a:ln>
+        </p:spPr>
+        <p:style>
+          <a:lnRef idx="1">
+            <a:schemeClr val="accent1"/>
+          </a:lnRef>
+          <a:fillRef idx="3">
+            <a:schemeClr val="accent1"/>
+          </a:fillRef>
+          <a:effectRef idx="2">
+            <a:schemeClr val="accent1"/>
+          </a:effectRef>
+          <a:fontRef idx="minor">
+            <a:schemeClr val="lt1"/>
+          </a:fontRef>
+        </p:style>
+        <p:txBody>
+          <a:bodyPr rtlCol="0" anchor="ctr"/>
+          <a:lstStyle/>
+          <a:p>
+            <a:pPr algn="ctr"/>
+          </a:p>
+        </p:txBody>
+      </p:sp>
+      <p:sp>
+        <p:nvSpPr>
+          <p:cNvPr id="7" name="TextBox 6"/>
+          <p:cNvSpPr txBox="1"/>
+          <p:nvPr/>
+        </p:nvSpPr>
+        <p:spPr>
+          <a:xfrm>
+            <a:off x="4663440" y="2468880"/>
+            <a:ext cx="2743200" cy="457200"/>
+          </a:xfrm>
+          <a:prstGeom prst="rect">
+            <a:avLst/>
+          </a:prstGeom>
+          <a:noFill/>
+        </p:spPr>
+        <p:txBody>
+          <a:bodyPr wrap="square">
+            <a:spAutoFit/>
+          </a:bodyPr>
+          <a:lstStyle/>
+          <a:p>
+            <a:pPr algn="ctr">
+              <a:defRPr sz="2200" b="1">
+                <a:solidFill>
+                  <a:srgbClr val="FDA05B"/>
+                </a:solidFill>
+                <a:latin typeface="Segoe UI"/>
+              </a:defRPr>
+            </a:pPr>
+            <a:r>
+              <a:t>2. Transformation</a:t>
+            </a:r>
+          </a:p>
+        </p:txBody>
+      </p:sp>
+      <p:sp>
+        <p:nvSpPr>
+          <p:cNvPr id="8" name="TextBox 7"/>
+          <p:cNvSpPr txBox="1"/>
+          <p:nvPr/>
+        </p:nvSpPr>
+        <p:spPr>
+          <a:xfrm>
+            <a:off x="4663440" y="3200400"/>
+            <a:ext cx="2743200" cy="1371600"/>
+          </a:xfrm>
+          <a:prstGeom prst="rect">
+            <a:avLst/>
+          </a:prstGeom>
+          <a:noFill/>
+        </p:spPr>
+        <p:txBody>
+          <a:bodyPr wrap="square">
+            <a:spAutoFit/>
+          </a:bodyPr>
+          <a:lstStyle/>
+          <a:p>
+            <a:pPr algn="ctr">
+              <a:defRPr sz="1400" b="0">
+                <a:solidFill>
+                  <a:srgbClr val="C8D0D9"/>
+                </a:solidFill>
+                <a:latin typeface="Segoe UI"/>
+              </a:defRPr>
+            </a:pPr>
+            <a:r>
+              <a:t>Mathematically derives Actual vs Scheduled durations.</a:t>
+            </a:r>
+            <a:br/>
+            <a:br/>
+            <a:r>
+              <a:t>Heuristically adjusts for complex edge-cases like overnight flight arrivals spanning multiple days.</a:t>
+            </a:r>
+          </a:p>
+        </p:txBody>
+      </p:sp>
+      <p:sp>
+        <p:nvSpPr>
+          <p:cNvPr id="9" name="Rounded Rectangle 8"/>
+          <p:cNvSpPr/>
+          <p:nvPr/>
+        </p:nvSpPr>
+        <p:spPr>
+          <a:xfrm>
+            <a:off x="8229600" y="2286000"/>
+            <a:ext cx="2926080" cy="2743200"/>
+          </a:xfrm>
+          <a:prstGeom prst="roundRect">
+            <a:avLst/>
+          </a:prstGeom>
+          <a:solidFill>
+            <a:srgbClr val="14325A"/>
+          </a:solidFill>
+          <a:ln>
+            <a:solidFill>
+              <a:srgbClr val="00D2D3"/>
+            </a:solidFill>
+          </a:ln>
+        </p:spPr>
+        <p:style>
+          <a:lnRef idx="1">
+            <a:schemeClr val="accent1"/>
+          </a:lnRef>
+          <a:fillRef idx="3">
+            <a:schemeClr val="accent1"/>
+          </a:fillRef>
+          <a:effectRef idx="2">
+            <a:schemeClr val="accent1"/>
+          </a:effectRef>
+          <a:fontRef idx="minor">
+            <a:schemeClr val="lt1"/>
+          </a:fontRef>
+        </p:style>
+        <p:txBody>
+          <a:bodyPr rtlCol="0" anchor="ctr"/>
+          <a:lstStyle/>
+          <a:p>
+            <a:pPr algn="ctr"/>
+          </a:p>
+        </p:txBody>
+      </p:sp>
+      <p:sp>
+        <p:nvSpPr>
+          <p:cNvPr id="10" name="TextBox 9"/>
+          <p:cNvSpPr txBox="1"/>
+          <p:nvPr/>
+        </p:nvSpPr>
+        <p:spPr>
+          <a:xfrm>
+            <a:off x="8321040" y="2468880"/>
+            <a:ext cx="2743200" cy="457200"/>
+          </a:xfrm>
+          <a:prstGeom prst="rect">
+            <a:avLst/>
+          </a:prstGeom>
+          <a:noFill/>
+        </p:spPr>
+        <p:txBody>
+          <a:bodyPr wrap="square">
+            <a:spAutoFit/>
+          </a:bodyPr>
+          <a:lstStyle/>
+          <a:p>
+            <a:pPr algn="ctr">
+              <a:defRPr sz="2200" b="1">
+                <a:solidFill>
+                  <a:srgbClr val="FDA05B"/>
+                </a:solidFill>
+                <a:latin typeface="Segoe UI"/>
+              </a:defRPr>
+            </a:pPr>
+            <a:r>
+              <a:t>3. SQLite Database</a:t>
+            </a:r>
+          </a:p>
+        </p:txBody>
+      </p:sp>
+      <p:sp>
+        <p:nvSpPr>
+          <p:cNvPr id="11" name="TextBox 10"/>
+          <p:cNvSpPr txBox="1"/>
+          <p:nvPr/>
+        </p:nvSpPr>
+        <p:spPr>
+          <a:xfrm>
+            <a:off x="8321040" y="3200400"/>
+            <a:ext cx="2743200" cy="1371600"/>
+          </a:xfrm>
+          <a:prstGeom prst="rect">
+            <a:avLst/>
+          </a:prstGeom>
+          <a:noFill/>
+        </p:spPr>
+        <p:txBody>
+          <a:bodyPr wrap="square">
+            <a:spAutoFit/>
+          </a:bodyPr>
+          <a:lstStyle/>
+          <a:p>
+            <a:pPr algn="ctr">
+              <a:defRPr sz="1400" b="0">
+                <a:solidFill>
+                  <a:srgbClr val="C8D0D9"/>
+                </a:solidFill>
+                <a:latin typeface="Segoe UI"/>
+              </a:defRPr>
+            </a:pPr>
+            <a:r>
+              <a:t>Loads clean data into a local 'operations.db' database.</a:t>
+            </a:r>
+            <a:br/>
+            <a:br/>
+            <a:r>
+              <a:t>Builds B-Tree indexes on Tail Numbers and Origins to guarantee rapid downstream SQL querying.</a:t>
             </a:r>
           </a:p>
         </p:txBody>
@@ -3335,6 +3874,14 @@
 <file path=ppt/slides/slide4.xml><?xml version="1.0" encoding="utf-8"?>
 <p:sld xmlns:a="http://schemas.openxmlformats.org/drawingml/2006/main" xmlns:p="http://schemas.openxmlformats.org/presentationml/2006/main" xmlns:r="http://schemas.openxmlformats.org/officeDocument/2006/relationships">
   <p:cSld>
+    <p:bg>
+      <p:bgPr>
+        <a:solidFill>
+          <a:srgbClr val="0C2340"/>
+        </a:solidFill>
+        <a:effectLst/>
+      </p:bgPr>
+    </p:bg>
     <p:spTree>
       <p:nvGrpSpPr>
         <p:cNvPr id="1" name=""/>
@@ -3344,66 +3891,164 @@
       <p:grpSpPr/>
       <p:sp>
         <p:nvSpPr>
-          <p:cNvPr id="2" name="Title 1"/>
-          <p:cNvSpPr>
-            <a:spLocks noGrp="1"/>
-          </p:cNvSpPr>
-          <p:nvPr>
-            <p:ph type="title"/>
-          </p:nvPr>
-        </p:nvSpPr>
-        <p:spPr/>
-        <p:txBody>
-          <a:bodyPr/>
-          <a:lstStyle/>
-          <a:p>
-            <a:r>
-              <a:t>How to Run the Pipeline</a:t>
-            </a:r>
-          </a:p>
-        </p:txBody>
-      </p:sp>
-      <p:sp>
-        <p:nvSpPr>
-          <p:cNvPr id="3" name="Content Placeholder 2"/>
-          <p:cNvSpPr>
-            <a:spLocks noGrp="1"/>
-          </p:cNvSpPr>
-          <p:nvPr>
-            <p:ph idx="1"/>
-          </p:nvPr>
-        </p:nvSpPr>
-        <p:spPr/>
-        <p:txBody>
-          <a:bodyPr/>
-          <a:lstStyle/>
-          <a:p>
-            <a:r>
-              <a:t>Step-by-step execution:</a:t>
-            </a:r>
-          </a:p>
-          <a:p>
-            <a:pPr lvl="1"/>
-            <a:r>
-              <a:t>Step 1: Install dependencies (pip install -r requirements.txt)</a:t>
-            </a:r>
-          </a:p>
-          <a:p>
-            <a:pPr lvl="1"/>
-            <a:r>
-              <a:t>Step 2: Build the Database (python src/db_setup.py)</a:t>
-            </a:r>
-          </a:p>
-          <a:p>
-            <a:pPr lvl="1"/>
-            <a:r>
-              <a:t>Step 3: Run the SQL Analytics (sqlite3 operations.db &lt; sql/turnaround_analytics.sql)</a:t>
-            </a:r>
-          </a:p>
-          <a:p>
-            <a:pPr lvl="1"/>
-            <a:r>
-              <a:t>Step 4: Run the ML Model (python src/train_model.py)</a:t>
+          <p:cNvPr id="2" name="TextBox 1"/>
+          <p:cNvSpPr txBox="1"/>
+          <p:nvPr/>
+        </p:nvSpPr>
+        <p:spPr>
+          <a:xfrm>
+            <a:off x="731520" y="457200"/>
+            <a:ext cx="10058400" cy="914400"/>
+          </a:xfrm>
+          <a:prstGeom prst="rect">
+            <a:avLst/>
+          </a:prstGeom>
+          <a:noFill/>
+        </p:spPr>
+        <p:txBody>
+          <a:bodyPr wrap="square">
+            <a:spAutoFit/>
+          </a:bodyPr>
+          <a:lstStyle/>
+          <a:p>
+            <a:pPr algn="l">
+              <a:defRPr sz="3600" b="1">
+                <a:solidFill>
+                  <a:srgbClr val="00D2D3"/>
+                </a:solidFill>
+                <a:latin typeface="Segoe UI"/>
+              </a:defRPr>
+            </a:pPr>
+            <a:r>
+              <a:t>Phase 2: The Analytical SQL Engine</a:t>
+            </a:r>
+          </a:p>
+        </p:txBody>
+      </p:sp>
+      <p:sp>
+        <p:nvSpPr>
+          <p:cNvPr id="3" name="TextBox 2"/>
+          <p:cNvSpPr txBox="1"/>
+          <p:nvPr/>
+        </p:nvSpPr>
+        <p:spPr>
+          <a:xfrm>
+            <a:off x="731520" y="1645920"/>
+            <a:ext cx="10515600" cy="4572000"/>
+          </a:xfrm>
+          <a:prstGeom prst="rect">
+            <a:avLst/>
+          </a:prstGeom>
+          <a:noFill/>
+        </p:spPr>
+        <p:txBody>
+          <a:bodyPr wrap="square">
+            <a:spAutoFit/>
+          </a:bodyPr>
+          <a:lstStyle/>
+          <a:p/>
+          <a:p>
+            <a:pPr>
+              <a:defRPr sz="2400" b="1">
+                <a:solidFill>
+                  <a:srgbClr val="FFFFFF"/>
+                </a:solidFill>
+                <a:latin typeface="Segoe UI"/>
+              </a:defRPr>
+            </a:pPr>
+            <a:r>
+              <a:t>Unlocking Network Intelligence using Advanced Window Functions</a:t>
+            </a:r>
+          </a:p>
+          <a:p>
+            <a:pPr lvl="1">
+              <a:defRPr sz="2200" b="1">
+                <a:solidFill>
+                  <a:srgbClr val="FDA05B"/>
+                </a:solidFill>
+                <a:latin typeface="Segoe UI"/>
+              </a:defRPr>
+            </a:pPr>
+            <a:r>
+              <a:t>Common Table Expressions (CTEs)</a:t>
+            </a:r>
+          </a:p>
+          <a:p>
+            <a:pPr lvl="2">
+              <a:defRPr sz="1800" b="0">
+                <a:solidFill>
+                  <a:srgbClr val="C8D0D9"/>
+                </a:solidFill>
+                <a:latin typeface="Segoe UI"/>
+              </a:defRPr>
+            </a:pPr>
+            <a:r>
+              <a:t>Instead of complex Python loops, we utilize highly optimized SQL CTEs to trace aircraft history.</a:t>
+            </a:r>
+          </a:p>
+          <a:p>
+            <a:pPr lvl="1">
+              <a:defRPr sz="2200" b="1">
+                <a:solidFill>
+                  <a:srgbClr val="FDA05B"/>
+                </a:solidFill>
+                <a:latin typeface="Segoe UI"/>
+              </a:defRPr>
+            </a:pPr>
+            <a:r>
+              <a:t>Physical Aircraft Sequencing [ LAG() ]</a:t>
+            </a:r>
+          </a:p>
+          <a:p>
+            <a:pPr lvl="2">
+              <a:defRPr sz="1800" b="0">
+                <a:solidFill>
+                  <a:srgbClr val="C8D0D9"/>
+                </a:solidFill>
+                <a:latin typeface="Segoe UI"/>
+              </a:defRPr>
+            </a:pPr>
+            <a:r>
+              <a:t>By partitioning data by 'Tail_Number' and ordering by 'Scheduled_Departure', we dynamically lookup the exact arrival time and location of the aircraft's prior flight.</a:t>
+            </a:r>
+          </a:p>
+          <a:p>
+            <a:pPr lvl="2">
+              <a:defRPr sz="1800" b="0">
+                <a:solidFill>
+                  <a:srgbClr val="C8D0D9"/>
+                </a:solidFill>
+                <a:latin typeface="Segoe UI"/>
+              </a:defRPr>
+            </a:pPr>
+            <a:r>
+              <a:t>This confirms physical aircraft continuity (Prior Destination = Current Origin) to calculate true ground turnaround metrics.</a:t>
+            </a:r>
+          </a:p>
+          <a:p>
+            <a:pPr lvl="1">
+              <a:defRPr sz="2200" b="1">
+                <a:solidFill>
+                  <a:srgbClr val="FDA05B"/>
+                </a:solidFill>
+                <a:latin typeface="Segoe UI"/>
+              </a:defRPr>
+            </a:pPr>
+            <a:r>
+              <a:t>Isolating Network Choke Points</a:t>
+            </a:r>
+          </a:p>
+          <a:p>
+            <a:pPr lvl="2">
+              <a:defRPr sz="1800" b="0">
+                <a:solidFill>
+                  <a:srgbClr val="C8D0D9"/>
+                </a:solidFill>
+                <a:latin typeface="Segoe UI"/>
+              </a:defRPr>
+            </a:pPr>
+            <a:r>
+              <a:t>We aggregate these metrics by Airport and Carrier, flagging flights where an inbound delay directly triggered an outbound delay, effectively creating a map of operational choke points.</a:t>
             </a:r>
           </a:p>
         </p:txBody>
@@ -3419,6 +4064,14 @@
 <file path=ppt/slides/slide5.xml><?xml version="1.0" encoding="utf-8"?>
 <p:sld xmlns:a="http://schemas.openxmlformats.org/drawingml/2006/main" xmlns:p="http://schemas.openxmlformats.org/presentationml/2006/main" xmlns:r="http://schemas.openxmlformats.org/officeDocument/2006/relationships">
   <p:cSld>
+    <p:bg>
+      <p:bgPr>
+        <a:solidFill>
+          <a:srgbClr val="0C2340"/>
+        </a:solidFill>
+        <a:effectLst/>
+      </p:bgPr>
+    </p:bg>
     <p:spTree>
       <p:nvGrpSpPr>
         <p:cNvPr id="1" name=""/>
@@ -3428,66 +4081,680 @@
       <p:grpSpPr/>
       <p:sp>
         <p:nvSpPr>
-          <p:cNvPr id="2" name="Title 1"/>
-          <p:cNvSpPr>
-            <a:spLocks noGrp="1"/>
-          </p:cNvSpPr>
-          <p:nvPr>
-            <p:ph type="title"/>
-          </p:nvPr>
-        </p:nvSpPr>
-        <p:spPr/>
-        <p:txBody>
-          <a:bodyPr/>
-          <a:lstStyle/>
-          <a:p>
-            <a:r>
-              <a:t>Model Results &amp; Financial Impact</a:t>
-            </a:r>
-          </a:p>
-        </p:txBody>
-      </p:sp>
-      <p:sp>
-        <p:nvSpPr>
-          <p:cNvPr id="3" name="Content Placeholder 2"/>
-          <p:cNvSpPr>
-            <a:spLocks noGrp="1"/>
-          </p:cNvSpPr>
-          <p:nvPr>
-            <p:ph idx="1"/>
-          </p:nvPr>
-        </p:nvSpPr>
-        <p:spPr/>
-        <p:txBody>
-          <a:bodyPr/>
-          <a:lstStyle/>
-          <a:p>
-            <a:r>
-              <a:t>Performance Benchmarks:</a:t>
-            </a:r>
-          </a:p>
-          <a:p>
-            <a:pPr lvl="1"/>
-            <a:r>
-              <a:t>Precision (78.4%): High accuracy when flagging a delay.</a:t>
-            </a:r>
-          </a:p>
-          <a:p>
-            <a:pPr lvl="1"/>
-            <a:r>
-              <a:t>Recall (65.9%): Successfully anticipated 66% of actual delays.</a:t>
-            </a:r>
-          </a:p>
-          <a:p>
-            <a:pPr lvl="1"/>
-            <a:r>
-              <a:t>Predicted Delay Cost Exposure: $51,204,225</a:t>
-            </a:r>
-          </a:p>
-          <a:p>
-            <a:pPr lvl="1"/>
-            <a:r>
-              <a:t>Potential Operational Savings: $10,240,845 (assuming 20% mitigation)</a:t>
+          <p:cNvPr id="2" name="TextBox 1"/>
+          <p:cNvSpPr txBox="1"/>
+          <p:nvPr/>
+        </p:nvSpPr>
+        <p:spPr>
+          <a:xfrm>
+            <a:off x="731520" y="457200"/>
+            <a:ext cx="10058400" cy="914400"/>
+          </a:xfrm>
+          <a:prstGeom prst="rect">
+            <a:avLst/>
+          </a:prstGeom>
+          <a:noFill/>
+        </p:spPr>
+        <p:txBody>
+          <a:bodyPr wrap="square">
+            <a:spAutoFit/>
+          </a:bodyPr>
+          <a:lstStyle/>
+          <a:p>
+            <a:pPr algn="l">
+              <a:defRPr sz="3600" b="1">
+                <a:solidFill>
+                  <a:srgbClr val="00D2D3"/>
+                </a:solidFill>
+                <a:latin typeface="Segoe UI"/>
+              </a:defRPr>
+            </a:pPr>
+            <a:r>
+              <a:t>Phase 3: Machine Learning &amp; Prediction</a:t>
+            </a:r>
+          </a:p>
+        </p:txBody>
+      </p:sp>
+      <p:sp>
+        <p:nvSpPr>
+          <p:cNvPr id="3" name="TextBox 2"/>
+          <p:cNvSpPr txBox="1"/>
+          <p:nvPr/>
+        </p:nvSpPr>
+        <p:spPr>
+          <a:xfrm>
+            <a:off x="731520" y="1645920"/>
+            <a:ext cx="5486400" cy="4572000"/>
+          </a:xfrm>
+          <a:prstGeom prst="rect">
+            <a:avLst/>
+          </a:prstGeom>
+          <a:noFill/>
+        </p:spPr>
+        <p:txBody>
+          <a:bodyPr wrap="square">
+            <a:spAutoFit/>
+          </a:bodyPr>
+          <a:lstStyle/>
+          <a:p/>
+          <a:p>
+            <a:pPr>
+              <a:defRPr sz="2400" b="1">
+                <a:solidFill>
+                  <a:srgbClr val="FDA05B"/>
+                </a:solidFill>
+                <a:latin typeface="Segoe UI"/>
+              </a:defRPr>
+            </a:pPr>
+            <a:r>
+              <a:t>The Goal</a:t>
+            </a:r>
+          </a:p>
+          <a:p>
+            <a:pPr lvl="1">
+              <a:defRPr sz="1800" b="0">
+                <a:solidFill>
+                  <a:srgbClr val="C8D0D9"/>
+                </a:solidFill>
+                <a:latin typeface="Segoe UI"/>
+              </a:defRPr>
+            </a:pPr>
+            <a:r>
+              <a:t>Predict if a flight will breach its turnaround buffer and cause severe downstream delays.</a:t>
+            </a:r>
+          </a:p>
+          <a:p>
+            <a:pPr>
+              <a:defRPr sz="2400" b="1">
+                <a:solidFill>
+                  <a:srgbClr val="FDA05B"/>
+                </a:solidFill>
+                <a:latin typeface="Segoe UI"/>
+              </a:defRPr>
+            </a:pPr>
+            <a:r>
+              <a:t>Feature Engineering</a:t>
+            </a:r>
+          </a:p>
+          <a:p>
+            <a:pPr lvl="1">
+              <a:defRPr sz="1600" b="0">
+                <a:solidFill>
+                  <a:srgbClr val="FFFFFF"/>
+                </a:solidFill>
+                <a:latin typeface="Segoe UI"/>
+              </a:defRPr>
+            </a:pPr>
+            <a:r>
+              <a:t>Turn Buffer Volume (Mins)</a:t>
+            </a:r>
+          </a:p>
+          <a:p>
+            <a:pPr lvl="1">
+              <a:defRPr sz="1600" b="0">
+                <a:solidFill>
+                  <a:srgbClr val="FFFFFF"/>
+                </a:solidFill>
+                <a:latin typeface="Segoe UI"/>
+              </a:defRPr>
+            </a:pPr>
+            <a:r>
+              <a:t>Inbound Delay Stress</a:t>
+            </a:r>
+          </a:p>
+          <a:p>
+            <a:pPr lvl="1">
+              <a:defRPr sz="1600" b="0">
+                <a:solidFill>
+                  <a:srgbClr val="FFFFFF"/>
+                </a:solidFill>
+                <a:latin typeface="Segoe UI"/>
+              </a:defRPr>
+            </a:pPr>
+            <a:r>
+              <a:t>Route Congestion Profiles</a:t>
+            </a:r>
+          </a:p>
+          <a:p>
+            <a:pPr lvl="1">
+              <a:defRPr sz="1600" b="0">
+                <a:solidFill>
+                  <a:srgbClr val="FFFFFF"/>
+                </a:solidFill>
+                <a:latin typeface="Segoe UI"/>
+              </a:defRPr>
+            </a:pPr>
+            <a:r>
+              <a:t>Tail-Number Historical Delay Frequencies</a:t>
+            </a:r>
+          </a:p>
+          <a:p>
+            <a:pPr>
+              <a:defRPr sz="2400" b="1">
+                <a:solidFill>
+                  <a:srgbClr val="FDA05B"/>
+                </a:solidFill>
+                <a:latin typeface="Segoe UI"/>
+              </a:defRPr>
+            </a:pPr>
+            <a:r>
+              <a:t>The Algorithm</a:t>
+            </a:r>
+          </a:p>
+          <a:p>
+            <a:pPr lvl="1">
+              <a:defRPr sz="1800" b="0">
+                <a:solidFill>
+                  <a:srgbClr val="C8D0D9"/>
+                </a:solidFill>
+                <a:latin typeface="Segoe UI"/>
+              </a:defRPr>
+            </a:pPr>
+            <a:r>
+              <a:t>Random Forest Classifier. We explicitly combat dataset class-imbalance by utilizing computationally balanced class weights.</a:t>
+            </a:r>
+          </a:p>
+        </p:txBody>
+      </p:sp>
+      <p:sp>
+        <p:nvSpPr>
+          <p:cNvPr id="4" name="Rounded Rectangle 3"/>
+          <p:cNvSpPr/>
+          <p:nvPr/>
+        </p:nvSpPr>
+        <p:spPr>
+          <a:xfrm>
+            <a:off x="6858000" y="1828800"/>
+            <a:ext cx="4572000" cy="3657600"/>
+          </a:xfrm>
+          <a:prstGeom prst="roundRect">
+            <a:avLst/>
+          </a:prstGeom>
+          <a:solidFill>
+            <a:srgbClr val="14325A"/>
+          </a:solidFill>
+          <a:ln>
+            <a:solidFill>
+              <a:srgbClr val="00D2D3"/>
+            </a:solidFill>
+          </a:ln>
+        </p:spPr>
+        <p:style>
+          <a:lnRef idx="1">
+            <a:schemeClr val="accent1"/>
+          </a:lnRef>
+          <a:fillRef idx="3">
+            <a:schemeClr val="accent1"/>
+          </a:fillRef>
+          <a:effectRef idx="2">
+            <a:schemeClr val="accent1"/>
+          </a:effectRef>
+          <a:fontRef idx="minor">
+            <a:schemeClr val="lt1"/>
+          </a:fontRef>
+        </p:style>
+        <p:txBody>
+          <a:bodyPr rtlCol="0" anchor="ctr"/>
+          <a:lstStyle/>
+          <a:p>
+            <a:pPr algn="ctr"/>
+          </a:p>
+        </p:txBody>
+      </p:sp>
+      <p:sp>
+        <p:nvSpPr>
+          <p:cNvPr id="5" name="TextBox 4"/>
+          <p:cNvSpPr txBox="1"/>
+          <p:nvPr/>
+        </p:nvSpPr>
+        <p:spPr>
+          <a:xfrm>
+            <a:off x="6858000" y="2011680"/>
+            <a:ext cx="4572000" cy="457200"/>
+          </a:xfrm>
+          <a:prstGeom prst="rect">
+            <a:avLst/>
+          </a:prstGeom>
+          <a:noFill/>
+        </p:spPr>
+        <p:txBody>
+          <a:bodyPr wrap="square">
+            <a:spAutoFit/>
+          </a:bodyPr>
+          <a:lstStyle/>
+          <a:p>
+            <a:pPr algn="ctr">
+              <a:defRPr sz="2800" b="1">
+                <a:solidFill>
+                  <a:srgbClr val="FDA05B"/>
+                </a:solidFill>
+                <a:latin typeface="Segoe UI"/>
+              </a:defRPr>
+            </a:pPr>
+            <a:r>
+              <a:t>Model Performance</a:t>
+            </a:r>
+          </a:p>
+        </p:txBody>
+      </p:sp>
+      <p:sp>
+        <p:nvSpPr>
+          <p:cNvPr id="6" name="TextBox 5"/>
+          <p:cNvSpPr txBox="1"/>
+          <p:nvPr/>
+        </p:nvSpPr>
+        <p:spPr>
+          <a:xfrm>
+            <a:off x="7132320" y="2743200"/>
+            <a:ext cx="4023360" cy="2286000"/>
+          </a:xfrm>
+          <a:prstGeom prst="rect">
+            <a:avLst/>
+          </a:prstGeom>
+          <a:noFill/>
+        </p:spPr>
+        <p:txBody>
+          <a:bodyPr wrap="square">
+            <a:spAutoFit/>
+          </a:bodyPr>
+          <a:lstStyle/>
+          <a:p>
+            <a:pPr algn="l">
+              <a:defRPr sz="2000" b="0">
+                <a:solidFill>
+                  <a:srgbClr val="FFFFFF"/>
+                </a:solidFill>
+                <a:latin typeface="Segoe UI"/>
+              </a:defRPr>
+            </a:pPr>
+            <a:r>
+              <a:t>PR-AUC Score: 0.82</a:t>
+            </a:r>
+            <a:br/>
+            <a:br/>
+            <a:r>
+              <a:t>Precision: 78.4%</a:t>
+            </a:r>
+            <a:br/>
+            <a:r>
+              <a:t>(High accuracy when flagging delays)</a:t>
+            </a:r>
+            <a:br/>
+            <a:br/>
+            <a:r>
+              <a:t>Recall: 65.9%</a:t>
+            </a:r>
+            <a:br/>
+            <a:r>
+              <a:t>(Caught 66% of all actual delays)</a:t>
+            </a:r>
+          </a:p>
+        </p:txBody>
+      </p:sp>
+    </p:spTree>
+  </p:cSld>
+  <p:clrMapOvr>
+    <a:masterClrMapping/>
+  </p:clrMapOvr>
+</p:sld>
+</file>
+
+<file path=ppt/slides/slide6.xml><?xml version="1.0" encoding="utf-8"?>
+<p:sld xmlns:a="http://schemas.openxmlformats.org/drawingml/2006/main" xmlns:p="http://schemas.openxmlformats.org/presentationml/2006/main" xmlns:r="http://schemas.openxmlformats.org/officeDocument/2006/relationships">
+  <p:cSld>
+    <p:bg>
+      <p:bgPr>
+        <a:solidFill>
+          <a:srgbClr val="0C2340"/>
+        </a:solidFill>
+        <a:effectLst/>
+      </p:bgPr>
+    </p:bg>
+    <p:spTree>
+      <p:nvGrpSpPr>
+        <p:cNvPr id="1" name=""/>
+        <p:cNvGrpSpPr/>
+        <p:nvPr/>
+      </p:nvGrpSpPr>
+      <p:grpSpPr/>
+      <p:sp>
+        <p:nvSpPr>
+          <p:cNvPr id="2" name="TextBox 1"/>
+          <p:cNvSpPr txBox="1"/>
+          <p:nvPr/>
+        </p:nvSpPr>
+        <p:spPr>
+          <a:xfrm>
+            <a:off x="731520" y="457200"/>
+            <a:ext cx="10058400" cy="914400"/>
+          </a:xfrm>
+          <a:prstGeom prst="rect">
+            <a:avLst/>
+          </a:prstGeom>
+          <a:noFill/>
+        </p:spPr>
+        <p:txBody>
+          <a:bodyPr wrap="square">
+            <a:spAutoFit/>
+          </a:bodyPr>
+          <a:lstStyle/>
+          <a:p>
+            <a:pPr algn="l">
+              <a:defRPr sz="3600" b="1">
+                <a:solidFill>
+                  <a:srgbClr val="00D2D3"/>
+                </a:solidFill>
+                <a:latin typeface="Segoe UI"/>
+              </a:defRPr>
+            </a:pPr>
+            <a:r>
+              <a:t>Phase 4: Operational Financial Translation</a:t>
+            </a:r>
+          </a:p>
+        </p:txBody>
+      </p:sp>
+      <p:sp>
+        <p:nvSpPr>
+          <p:cNvPr id="3" name="TextBox 2"/>
+          <p:cNvSpPr txBox="1"/>
+          <p:nvPr/>
+        </p:nvSpPr>
+        <p:spPr>
+          <a:xfrm>
+            <a:off x="731520" y="1371600"/>
+            <a:ext cx="10058400" cy="731520"/>
+          </a:xfrm>
+          <a:prstGeom prst="rect">
+            <a:avLst/>
+          </a:prstGeom>
+          <a:noFill/>
+        </p:spPr>
+        <p:txBody>
+          <a:bodyPr wrap="square">
+            <a:spAutoFit/>
+          </a:bodyPr>
+          <a:lstStyle/>
+          <a:p>
+            <a:pPr algn="l">
+              <a:defRPr sz="2400" b="0">
+                <a:solidFill>
+                  <a:srgbClr val="C8D0D9"/>
+                </a:solidFill>
+                <a:latin typeface="Segoe UI"/>
+              </a:defRPr>
+            </a:pPr>
+            <a:r>
+              <a:t>Translating data science metrics into executive financial value.</a:t>
+            </a:r>
+          </a:p>
+        </p:txBody>
+      </p:sp>
+      <p:sp>
+        <p:nvSpPr>
+          <p:cNvPr id="4" name="Rectangle 3"/>
+          <p:cNvSpPr/>
+          <p:nvPr/>
+        </p:nvSpPr>
+        <p:spPr>
+          <a:xfrm>
+            <a:off x="1371600" y="2560320"/>
+            <a:ext cx="4114800" cy="2286000"/>
+          </a:xfrm>
+          <a:prstGeom prst="rect">
+            <a:avLst/>
+          </a:prstGeom>
+          <a:solidFill>
+            <a:srgbClr val="281414"/>
+          </a:solidFill>
+          <a:ln>
+            <a:solidFill>
+              <a:srgbClr val="FF3232"/>
+            </a:solidFill>
+          </a:ln>
+        </p:spPr>
+        <p:style>
+          <a:lnRef idx="1">
+            <a:schemeClr val="accent1"/>
+          </a:lnRef>
+          <a:fillRef idx="3">
+            <a:schemeClr val="accent1"/>
+          </a:fillRef>
+          <a:effectRef idx="2">
+            <a:schemeClr val="accent1"/>
+          </a:effectRef>
+          <a:fontRef idx="minor">
+            <a:schemeClr val="lt1"/>
+          </a:fontRef>
+        </p:style>
+        <p:txBody>
+          <a:bodyPr rtlCol="0" anchor="ctr"/>
+          <a:lstStyle/>
+          <a:p>
+            <a:pPr algn="ctr"/>
+          </a:p>
+        </p:txBody>
+      </p:sp>
+      <p:sp>
+        <p:nvSpPr>
+          <p:cNvPr id="5" name="TextBox 4"/>
+          <p:cNvSpPr txBox="1"/>
+          <p:nvPr/>
+        </p:nvSpPr>
+        <p:spPr>
+          <a:xfrm>
+            <a:off x="1371600" y="2926080"/>
+            <a:ext cx="4114800" cy="457200"/>
+          </a:xfrm>
+          <a:prstGeom prst="rect">
+            <a:avLst/>
+          </a:prstGeom>
+          <a:noFill/>
+        </p:spPr>
+        <p:txBody>
+          <a:bodyPr wrap="square">
+            <a:spAutoFit/>
+          </a:bodyPr>
+          <a:lstStyle/>
+          <a:p>
+            <a:pPr algn="ctr">
+              <a:defRPr sz="2200" b="0">
+                <a:solidFill>
+                  <a:srgbClr val="C8D0D9"/>
+                </a:solidFill>
+                <a:latin typeface="Segoe UI"/>
+              </a:defRPr>
+            </a:pPr>
+            <a:r>
+              <a:t>Predicted Delay Cost Exposure</a:t>
+            </a:r>
+          </a:p>
+        </p:txBody>
+      </p:sp>
+      <p:sp>
+        <p:nvSpPr>
+          <p:cNvPr id="6" name="TextBox 5"/>
+          <p:cNvSpPr txBox="1"/>
+          <p:nvPr/>
+        </p:nvSpPr>
+        <p:spPr>
+          <a:xfrm>
+            <a:off x="1371600" y="3474720"/>
+            <a:ext cx="4114800" cy="914400"/>
+          </a:xfrm>
+          <a:prstGeom prst="rect">
+            <a:avLst/>
+          </a:prstGeom>
+          <a:noFill/>
+        </p:spPr>
+        <p:txBody>
+          <a:bodyPr wrap="square">
+            <a:spAutoFit/>
+          </a:bodyPr>
+          <a:lstStyle/>
+          <a:p>
+            <a:pPr algn="ctr">
+              <a:defRPr sz="4400" b="1">
+                <a:solidFill>
+                  <a:srgbClr val="FF6464"/>
+                </a:solidFill>
+                <a:latin typeface="Segoe UI"/>
+              </a:defRPr>
+            </a:pPr>
+            <a:r>
+              <a:t>$51.2 Million</a:t>
+            </a:r>
+          </a:p>
+        </p:txBody>
+      </p:sp>
+      <p:sp>
+        <p:nvSpPr>
+          <p:cNvPr id="7" name="Rectangle 6"/>
+          <p:cNvSpPr/>
+          <p:nvPr/>
+        </p:nvSpPr>
+        <p:spPr>
+          <a:xfrm>
+            <a:off x="6675120" y="2560320"/>
+            <a:ext cx="4114800" cy="2286000"/>
+          </a:xfrm>
+          <a:prstGeom prst="rect">
+            <a:avLst/>
+          </a:prstGeom>
+          <a:solidFill>
+            <a:srgbClr val="142814"/>
+          </a:solidFill>
+          <a:ln>
+            <a:solidFill>
+              <a:srgbClr val="32FF32"/>
+            </a:solidFill>
+          </a:ln>
+        </p:spPr>
+        <p:style>
+          <a:lnRef idx="1">
+            <a:schemeClr val="accent1"/>
+          </a:lnRef>
+          <a:fillRef idx="3">
+            <a:schemeClr val="accent1"/>
+          </a:fillRef>
+          <a:effectRef idx="2">
+            <a:schemeClr val="accent1"/>
+          </a:effectRef>
+          <a:fontRef idx="minor">
+            <a:schemeClr val="lt1"/>
+          </a:fontRef>
+        </p:style>
+        <p:txBody>
+          <a:bodyPr rtlCol="0" anchor="ctr"/>
+          <a:lstStyle/>
+          <a:p>
+            <a:pPr algn="ctr"/>
+          </a:p>
+        </p:txBody>
+      </p:sp>
+      <p:sp>
+        <p:nvSpPr>
+          <p:cNvPr id="8" name="TextBox 7"/>
+          <p:cNvSpPr txBox="1"/>
+          <p:nvPr/>
+        </p:nvSpPr>
+        <p:spPr>
+          <a:xfrm>
+            <a:off x="6675120" y="2926080"/>
+            <a:ext cx="4114800" cy="457200"/>
+          </a:xfrm>
+          <a:prstGeom prst="rect">
+            <a:avLst/>
+          </a:prstGeom>
+          <a:noFill/>
+        </p:spPr>
+        <p:txBody>
+          <a:bodyPr wrap="square">
+            <a:spAutoFit/>
+          </a:bodyPr>
+          <a:lstStyle/>
+          <a:p>
+            <a:pPr algn="ctr">
+              <a:defRPr sz="2200" b="0">
+                <a:solidFill>
+                  <a:srgbClr val="C8D0D9"/>
+                </a:solidFill>
+                <a:latin typeface="Segoe UI"/>
+              </a:defRPr>
+            </a:pPr>
+            <a:r>
+              <a:t>Potential Operational Savings</a:t>
+            </a:r>
+          </a:p>
+        </p:txBody>
+      </p:sp>
+      <p:sp>
+        <p:nvSpPr>
+          <p:cNvPr id="9" name="TextBox 8"/>
+          <p:cNvSpPr txBox="1"/>
+          <p:nvPr/>
+        </p:nvSpPr>
+        <p:spPr>
+          <a:xfrm>
+            <a:off x="6675120" y="3474720"/>
+            <a:ext cx="4114800" cy="914400"/>
+          </a:xfrm>
+          <a:prstGeom prst="rect">
+            <a:avLst/>
+          </a:prstGeom>
+          <a:noFill/>
+        </p:spPr>
+        <p:txBody>
+          <a:bodyPr wrap="square">
+            <a:spAutoFit/>
+          </a:bodyPr>
+          <a:lstStyle/>
+          <a:p>
+            <a:pPr algn="ctr">
+              <a:defRPr sz="4400" b="1">
+                <a:solidFill>
+                  <a:srgbClr val="64FF64"/>
+                </a:solidFill>
+                <a:latin typeface="Segoe UI"/>
+              </a:defRPr>
+            </a:pPr>
+            <a:r>
+              <a:t>$10.2 Million</a:t>
+            </a:r>
+          </a:p>
+        </p:txBody>
+      </p:sp>
+      <p:sp>
+        <p:nvSpPr>
+          <p:cNvPr id="10" name="TextBox 9"/>
+          <p:cNvSpPr txBox="1"/>
+          <p:nvPr/>
+        </p:nvSpPr>
+        <p:spPr>
+          <a:xfrm>
+            <a:off x="6675120" y="4389120"/>
+            <a:ext cx="4114800" cy="457200"/>
+          </a:xfrm>
+          <a:prstGeom prst="rect">
+            <a:avLst/>
+          </a:prstGeom>
+          <a:noFill/>
+        </p:spPr>
+        <p:txBody>
+          <a:bodyPr wrap="square">
+            <a:spAutoFit/>
+          </a:bodyPr>
+          <a:lstStyle/>
+          <a:p>
+            <a:pPr algn="ctr">
+              <a:defRPr sz="1400" b="0">
+                <a:solidFill>
+                  <a:srgbClr val="C8D0D9"/>
+                </a:solidFill>
+                <a:latin typeface="Segoe UI"/>
+              </a:defRPr>
+            </a:pPr>
+            <a:r>
+              <a:t>Assuming 20% Intervention Mitigation</a:t>
             </a:r>
           </a:p>
         </p:txBody>

</xml_diff>

<commit_message>
design: Redesign PPTX with visual assets, background images, and rich layouts
</commit_message>
<xml_diff>
--- a/Workflow_Presentation.pptx
+++ b/Workflow_Presentation.pptx
@@ -3101,28 +3101,47 @@
         <p:nvPr/>
       </p:nvGrpSpPr>
       <p:grpSpPr/>
-      <p:sp>
-        <p:nvSpPr>
-          <p:cNvPr id="2" name="Rectangle 1"/>
+      <p:pic>
+        <p:nvPicPr>
+          <p:cNvPr id="2" name="Picture 1" descr="airplane.jpg"/>
+          <p:cNvPicPr>
+            <a:picLocks noChangeAspect="1"/>
+          </p:cNvPicPr>
+          <p:nvPr/>
+        </p:nvPicPr>
+        <p:blipFill>
+          <a:blip r:embed="rId2"/>
+          <a:stretch>
+            <a:fillRect/>
+          </a:stretch>
+        </p:blipFill>
+        <p:spPr>
+          <a:xfrm>
+            <a:off x="0" y="0"/>
+            <a:ext cx="12191695" cy="6804667"/>
+          </a:xfrm>
+          <a:prstGeom prst="rect">
+            <a:avLst/>
+          </a:prstGeom>
+        </p:spPr>
+      </p:pic>
+      <p:sp>
+        <p:nvSpPr>
+          <p:cNvPr id="3" name="Rectangle 2"/>
           <p:cNvSpPr/>
           <p:nvPr/>
         </p:nvSpPr>
         <p:spPr>
           <a:xfrm>
-            <a:off x="0" y="3200400"/>
-            <a:ext cx="12191695" cy="91440"/>
+            <a:off x="0" y="0"/>
+            <a:ext cx="12191695" cy="6858000"/>
           </a:xfrm>
           <a:prstGeom prst="rect">
             <a:avLst/>
           </a:prstGeom>
           <a:solidFill>
-            <a:srgbClr val="00D2D3"/>
+            <a:srgbClr val="0A0A1E"/>
           </a:solidFill>
-          <a:ln>
-            <a:solidFill>
-              <a:srgbClr val="00D2D3"/>
-            </a:solidFill>
-          </a:ln>
         </p:spPr>
         <p:style>
           <a:lnRef idx="1">
@@ -3148,13 +3167,58 @@
       </p:sp>
       <p:sp>
         <p:nvSpPr>
-          <p:cNvPr id="3" name="TextBox 2"/>
+          <p:cNvPr id="4" name="Rectangle 3"/>
+          <p:cNvSpPr/>
+          <p:nvPr/>
+        </p:nvSpPr>
+        <p:spPr>
+          <a:xfrm>
+            <a:off x="0" y="1828800"/>
+            <a:ext cx="12191695" cy="3200400"/>
+          </a:xfrm>
+          <a:prstGeom prst="rect">
+            <a:avLst/>
+          </a:prstGeom>
+          <a:solidFill>
+            <a:srgbClr val="0C2340"/>
+          </a:solidFill>
+          <a:ln>
+            <a:solidFill>
+              <a:srgbClr val="00D2D3"/>
+            </a:solidFill>
+          </a:ln>
+        </p:spPr>
+        <p:style>
+          <a:lnRef idx="1">
+            <a:schemeClr val="accent1"/>
+          </a:lnRef>
+          <a:fillRef idx="3">
+            <a:schemeClr val="accent1"/>
+          </a:fillRef>
+          <a:effectRef idx="2">
+            <a:schemeClr val="accent1"/>
+          </a:effectRef>
+          <a:fontRef idx="minor">
+            <a:schemeClr val="lt1"/>
+          </a:fontRef>
+        </p:style>
+        <p:txBody>
+          <a:bodyPr rtlCol="0" anchor="ctr"/>
+          <a:lstStyle/>
+          <a:p>
+            <a:pPr algn="ctr"/>
+          </a:p>
+        </p:txBody>
+      </p:sp>
+      <p:sp>
+        <p:nvSpPr>
+          <p:cNvPr id="5" name="TextBox 4"/>
           <p:cNvSpPr txBox="1"/>
           <p:nvPr/>
         </p:nvSpPr>
         <p:spPr>
           <a:xfrm>
-            <a:off x="914400" y="1645920"/>
+            <a:off x="914400" y="2011680"/>
             <a:ext cx="10058400" cy="1371600"/>
           </a:xfrm>
           <a:prstGeom prst="rect">
@@ -3188,13 +3252,13 @@
       </p:sp>
       <p:sp>
         <p:nvSpPr>
-          <p:cNvPr id="4" name="TextBox 3"/>
+          <p:cNvPr id="6" name="TextBox 5"/>
           <p:cNvSpPr txBox="1"/>
           <p:nvPr/>
         </p:nvSpPr>
         <p:spPr>
           <a:xfrm>
-            <a:off x="914400" y="3657600"/>
+            <a:off x="914400" y="4023360"/>
             <a:ext cx="10058400" cy="914400"/>
           </a:xfrm>
           <a:prstGeom prst="rect">
@@ -3211,49 +3275,13 @@
             <a:pPr algn="ctr">
               <a:defRPr sz="2400" b="0">
                 <a:solidFill>
-                  <a:srgbClr val="C8D0D9"/>
+                  <a:srgbClr val="00D2D3"/>
                 </a:solidFill>
                 <a:latin typeface="Segoe UI"/>
               </a:defRPr>
             </a:pPr>
             <a:r>
               <a:t>Predicting Cascading Delays to Maximize Aircraft Utilization and Reduce Operational Costs</a:t>
-            </a:r>
-          </a:p>
-        </p:txBody>
-      </p:sp>
-      <p:sp>
-        <p:nvSpPr>
-          <p:cNvPr id="5" name="TextBox 4"/>
-          <p:cNvSpPr txBox="1"/>
-          <p:nvPr/>
-        </p:nvSpPr>
-        <p:spPr>
-          <a:xfrm>
-            <a:off x="914400" y="5943600"/>
-            <a:ext cx="10058400" cy="457200"/>
-          </a:xfrm>
-          <a:prstGeom prst="rect">
-            <a:avLst/>
-          </a:prstGeom>
-          <a:noFill/>
-        </p:spPr>
-        <p:txBody>
-          <a:bodyPr wrap="square">
-            <a:spAutoFit/>
-          </a:bodyPr>
-          <a:lstStyle/>
-          <a:p>
-            <a:pPr algn="ctr">
-              <a:defRPr sz="1600" b="1">
-                <a:solidFill>
-                  <a:srgbClr val="00D2D3"/>
-                </a:solidFill>
-                <a:latin typeface="Segoe UI"/>
-              </a:defRPr>
-            </a:pPr>
-            <a:r>
-              <a:t>End-to-End Analytics &amp; Machine Learning Pipeline</a:t>
             </a:r>
           </a:p>
         </p:txBody>
@@ -3329,7 +3357,7 @@
         <p:spPr>
           <a:xfrm>
             <a:off x="731520" y="1645920"/>
-            <a:ext cx="10515600" cy="4572000"/>
+            <a:ext cx="5943600" cy="4572000"/>
           </a:xfrm>
           <a:prstGeom prst="rect">
             <a:avLst/>
@@ -3352,7 +3380,7 @@
               </a:defRPr>
             </a:pPr>
             <a:r>
-              <a:t>Airlines operate on incredibly tight turnaround schedules to maximize aircraft utilization.</a:t>
+              <a:t>Airlines operate on incredibly tight turnaround schedules.</a:t>
             </a:r>
           </a:p>
           <a:p>
@@ -3378,7 +3406,7 @@
               </a:defRPr>
             </a:pPr>
             <a:r>
-              <a:t>The scheduled ground time allocated for cleaning, fueling, and boarding between an aircraft's arrival and its next departure.</a:t>
+              <a:t>The scheduled ground time allocated for cleaning, fueling, and boarding.</a:t>
             </a:r>
           </a:p>
           <a:p>
@@ -3391,7 +3419,7 @@
               </a:defRPr>
             </a:pPr>
             <a:r>
-              <a:t>The Domino Effect (Cascading Delays)</a:t>
+              <a:t>The Domino Effect</a:t>
             </a:r>
           </a:p>
           <a:p>
@@ -3404,7 +3432,7 @@
               </a:defRPr>
             </a:pPr>
             <a:r>
-              <a:t>When an aircraft arrives late, or ground operations exceed the buffer, the delay directly propagates to the next flight utilizing that same physical aircraft.</a:t>
+              <a:t>When ground operations exceed the buffer, the delay directly propagates to the next flight.</a:t>
             </a:r>
           </a:p>
           <a:p>
@@ -3417,7 +3445,7 @@
               </a:defRPr>
             </a:pPr>
             <a:r>
-              <a:t>The Financial Hemorrhage</a:t>
+              <a:t>Financial Hemorrhage</a:t>
             </a:r>
           </a:p>
           <a:p>
@@ -3430,11 +3458,40 @@
               </a:defRPr>
             </a:pPr>
             <a:r>
-              <a:t>According to the FAA and Airlines for America, every single minute of delay costs an airline approximately $75 in crew overtime, passenger compensations, and fuel inefficiencies.</a:t>
-            </a:r>
-          </a:p>
-        </p:txBody>
-      </p:sp>
+              <a:t>Every minute of delay costs approximately $75 in overtime and fuel inefficiencies.</a:t>
+            </a:r>
+          </a:p>
+        </p:txBody>
+      </p:sp>
+      <p:pic>
+        <p:nvPicPr>
+          <p:cNvPr id="4" name="Picture 3" descr="airplane.jpg"/>
+          <p:cNvPicPr>
+            <a:picLocks noChangeAspect="1"/>
+          </p:cNvPicPr>
+          <p:nvPr/>
+        </p:nvPicPr>
+        <p:blipFill>
+          <a:blip r:embed="rId2"/>
+          <a:stretch>
+            <a:fillRect/>
+          </a:stretch>
+        </p:blipFill>
+        <p:spPr>
+          <a:xfrm>
+            <a:off x="6858000" y="1645920"/>
+            <a:ext cx="4572000" cy="2551814"/>
+          </a:xfrm>
+          <a:prstGeom prst="rect">
+            <a:avLst/>
+          </a:prstGeom>
+          <a:ln>
+            <a:solidFill>
+              <a:srgbClr val="00D2D3"/>
+            </a:solidFill>
+          </a:ln>
+        </p:spPr>
+      </p:pic>
     </p:spTree>
   </p:cSld>
   <p:clrMapOvr>
@@ -3461,64 +3518,47 @@
         <p:nvPr/>
       </p:nvGrpSpPr>
       <p:grpSpPr/>
-      <p:sp>
-        <p:nvSpPr>
-          <p:cNvPr id="2" name="TextBox 1"/>
-          <p:cNvSpPr txBox="1"/>
+      <p:pic>
+        <p:nvPicPr>
+          <p:cNvPr id="2" name="Picture 1" descr="network.jpg"/>
+          <p:cNvPicPr>
+            <a:picLocks noChangeAspect="1"/>
+          </p:cNvPicPr>
           <p:nvPr/>
-        </p:nvSpPr>
-        <p:spPr>
-          <a:xfrm>
-            <a:off x="731520" y="457200"/>
-            <a:ext cx="9144000" cy="914400"/>
+        </p:nvPicPr>
+        <p:blipFill>
+          <a:blip r:embed="rId2"/>
+          <a:stretch>
+            <a:fillRect/>
+          </a:stretch>
+        </p:blipFill>
+        <p:spPr>
+          <a:xfrm>
+            <a:off x="0" y="0"/>
+            <a:ext cx="12191695" cy="6804667"/>
           </a:xfrm>
           <a:prstGeom prst="rect">
             <a:avLst/>
           </a:prstGeom>
-          <a:noFill/>
-        </p:spPr>
-        <p:txBody>
-          <a:bodyPr wrap="square">
-            <a:spAutoFit/>
-          </a:bodyPr>
-          <a:lstStyle/>
-          <a:p>
-            <a:pPr algn="l">
-              <a:defRPr sz="3600" b="1">
-                <a:solidFill>
-                  <a:srgbClr val="00D2D3"/>
-                </a:solidFill>
-                <a:latin typeface="Segoe UI"/>
-              </a:defRPr>
-            </a:pPr>
-            <a:r>
-              <a:t>Phase 1: Robust Data Ingestion &amp; Engineering</a:t>
-            </a:r>
-          </a:p>
-        </p:txBody>
-      </p:sp>
-      <p:sp>
-        <p:nvSpPr>
-          <p:cNvPr id="3" name="Rounded Rectangle 2"/>
+        </p:spPr>
+      </p:pic>
+      <p:sp>
+        <p:nvSpPr>
+          <p:cNvPr id="3" name="Rectangle 2"/>
           <p:cNvSpPr/>
           <p:nvPr/>
         </p:nvSpPr>
         <p:spPr>
           <a:xfrm>
-            <a:off x="914400" y="2286000"/>
-            <a:ext cx="2926080" cy="2743200"/>
-          </a:xfrm>
-          <a:prstGeom prst="roundRect">
+            <a:off x="0" y="0"/>
+            <a:ext cx="12191695" cy="6858000"/>
+          </a:xfrm>
+          <a:prstGeom prst="rect">
             <a:avLst/>
           </a:prstGeom>
           <a:solidFill>
-            <a:srgbClr val="14325A"/>
+            <a:srgbClr val="050F1E"/>
           </a:solidFill>
-          <a:ln>
-            <a:solidFill>
-              <a:srgbClr val="00D2D3"/>
-            </a:solidFill>
-          </a:ln>
         </p:spPr>
         <p:style>
           <a:lnRef idx="1">
@@ -3550,8 +3590,8 @@
         </p:nvSpPr>
         <p:spPr>
           <a:xfrm>
-            <a:off x="1005840" y="2468880"/>
-            <a:ext cx="2743200" cy="457200"/>
+            <a:off x="731520" y="457200"/>
+            <a:ext cx="9144000" cy="914400"/>
           </a:xfrm>
           <a:prstGeom prst="rect">
             <a:avLst/>
@@ -3564,70 +3604,29 @@
           </a:bodyPr>
           <a:lstStyle/>
           <a:p>
-            <a:pPr algn="ctr">
-              <a:defRPr sz="2200" b="1">
-                <a:solidFill>
-                  <a:srgbClr val="FDA05B"/>
+            <a:pPr algn="l">
+              <a:defRPr sz="3600" b="1">
+                <a:solidFill>
+                  <a:srgbClr val="00D2D3"/>
                 </a:solidFill>
                 <a:latin typeface="Segoe UI"/>
               </a:defRPr>
             </a:pPr>
             <a:r>
-              <a:t>1. Raw Data Parsing</a:t>
-            </a:r>
-          </a:p>
-        </p:txBody>
-      </p:sp>
-      <p:sp>
-        <p:nvSpPr>
-          <p:cNvPr id="5" name="TextBox 4"/>
-          <p:cNvSpPr txBox="1"/>
-          <p:nvPr/>
-        </p:nvSpPr>
-        <p:spPr>
-          <a:xfrm>
-            <a:off x="1005840" y="3200400"/>
-            <a:ext cx="2743200" cy="1371600"/>
-          </a:xfrm>
-          <a:prstGeom prst="rect">
-            <a:avLst/>
-          </a:prstGeom>
-          <a:noFill/>
-        </p:spPr>
-        <p:txBody>
-          <a:bodyPr wrap="square">
-            <a:spAutoFit/>
-          </a:bodyPr>
-          <a:lstStyle/>
-          <a:p>
-            <a:pPr algn="ctr">
-              <a:defRPr sz="1400" b="0">
-                <a:solidFill>
-                  <a:srgbClr val="C8D0D9"/>
-                </a:solidFill>
-                <a:latin typeface="Segoe UI"/>
-              </a:defRPr>
-            </a:pPr>
-            <a:r>
-              <a:t>Scans root directories for CSV/ZIP datasets.</a:t>
-            </a:r>
-            <a:br/>
-            <a:br/>
-            <a:r>
-              <a:t>Cleans missing values and transforms complex float time-series data into standard Python DateTime objects.</a:t>
-            </a:r>
-          </a:p>
-        </p:txBody>
-      </p:sp>
-      <p:sp>
-        <p:nvSpPr>
-          <p:cNvPr id="6" name="Rounded Rectangle 5"/>
+              <a:t>Phase 1: Robust Data Ingestion &amp; Engineering</a:t>
+            </a:r>
+          </a:p>
+        </p:txBody>
+      </p:sp>
+      <p:sp>
+        <p:nvSpPr>
+          <p:cNvPr id="5" name="Rounded Rectangle 4"/>
           <p:cNvSpPr/>
           <p:nvPr/>
         </p:nvSpPr>
         <p:spPr>
           <a:xfrm>
-            <a:off x="4572000" y="2286000"/>
+            <a:off x="914400" y="2286000"/>
             <a:ext cx="2926080" cy="2743200"/>
           </a:xfrm>
           <a:prstGeom prst="roundRect">
@@ -3666,13 +3665,13 @@
       </p:sp>
       <p:sp>
         <p:nvSpPr>
-          <p:cNvPr id="7" name="TextBox 6"/>
+          <p:cNvPr id="6" name="TextBox 5"/>
           <p:cNvSpPr txBox="1"/>
           <p:nvPr/>
         </p:nvSpPr>
         <p:spPr>
           <a:xfrm>
-            <a:off x="4663440" y="2468880"/>
+            <a:off x="1005840" y="2468880"/>
             <a:ext cx="2743200" cy="457200"/>
           </a:xfrm>
           <a:prstGeom prst="rect">
@@ -3695,20 +3694,20 @@
               </a:defRPr>
             </a:pPr>
             <a:r>
-              <a:t>2. Transformation</a:t>
-            </a:r>
-          </a:p>
-        </p:txBody>
-      </p:sp>
-      <p:sp>
-        <p:nvSpPr>
-          <p:cNvPr id="8" name="TextBox 7"/>
+              <a:t>1. Raw Data Parsing</a:t>
+            </a:r>
+          </a:p>
+        </p:txBody>
+      </p:sp>
+      <p:sp>
+        <p:nvSpPr>
+          <p:cNvPr id="7" name="TextBox 6"/>
           <p:cNvSpPr txBox="1"/>
           <p:nvPr/>
         </p:nvSpPr>
         <p:spPr>
           <a:xfrm>
-            <a:off x="4663440" y="3200400"/>
+            <a:off x="1005840" y="3200400"/>
             <a:ext cx="2743200" cy="1371600"/>
           </a:xfrm>
           <a:prstGeom prst="rect">
@@ -3725,31 +3724,31 @@
             <a:pPr algn="ctr">
               <a:defRPr sz="1400" b="0">
                 <a:solidFill>
-                  <a:srgbClr val="C8D0D9"/>
+                  <a:srgbClr val="FFFFFF"/>
                 </a:solidFill>
                 <a:latin typeface="Segoe UI"/>
               </a:defRPr>
             </a:pPr>
             <a:r>
-              <a:t>Mathematically derives Actual vs Scheduled durations.</a:t>
+              <a:t>Scans root directories for CSV/ZIP datasets.</a:t>
             </a:r>
             <a:br/>
             <a:br/>
             <a:r>
-              <a:t>Heuristically adjusts for complex edge-cases like overnight flight arrivals spanning multiple days.</a:t>
-            </a:r>
-          </a:p>
-        </p:txBody>
-      </p:sp>
-      <p:sp>
-        <p:nvSpPr>
-          <p:cNvPr id="9" name="Rounded Rectangle 8"/>
+              <a:t>Transforms complex float time-series data into standard DateTime objects.</a:t>
+            </a:r>
+          </a:p>
+        </p:txBody>
+      </p:sp>
+      <p:sp>
+        <p:nvSpPr>
+          <p:cNvPr id="8" name="Rounded Rectangle 7"/>
           <p:cNvSpPr/>
           <p:nvPr/>
         </p:nvSpPr>
         <p:spPr>
           <a:xfrm>
-            <a:off x="8229600" y="2286000"/>
+            <a:off x="4572000" y="2286000"/>
             <a:ext cx="2926080" cy="2743200"/>
           </a:xfrm>
           <a:prstGeom prst="roundRect">
@@ -3788,13 +3787,13 @@
       </p:sp>
       <p:sp>
         <p:nvSpPr>
-          <p:cNvPr id="10" name="TextBox 9"/>
+          <p:cNvPr id="9" name="TextBox 8"/>
           <p:cNvSpPr txBox="1"/>
           <p:nvPr/>
         </p:nvSpPr>
         <p:spPr>
           <a:xfrm>
-            <a:off x="8321040" y="2468880"/>
+            <a:off x="4663440" y="2468880"/>
             <a:ext cx="2743200" cy="457200"/>
           </a:xfrm>
           <a:prstGeom prst="rect">
@@ -3817,20 +3816,20 @@
               </a:defRPr>
             </a:pPr>
             <a:r>
-              <a:t>3. SQLite Database</a:t>
-            </a:r>
-          </a:p>
-        </p:txBody>
-      </p:sp>
-      <p:sp>
-        <p:nvSpPr>
-          <p:cNvPr id="11" name="TextBox 10"/>
+              <a:t>2. Transformation</a:t>
+            </a:r>
+          </a:p>
+        </p:txBody>
+      </p:sp>
+      <p:sp>
+        <p:nvSpPr>
+          <p:cNvPr id="10" name="TextBox 9"/>
           <p:cNvSpPr txBox="1"/>
           <p:nvPr/>
         </p:nvSpPr>
         <p:spPr>
           <a:xfrm>
-            <a:off x="8321040" y="3200400"/>
+            <a:off x="4663440" y="3200400"/>
             <a:ext cx="2743200" cy="1371600"/>
           </a:xfrm>
           <a:prstGeom prst="rect">
@@ -3847,18 +3846,140 @@
             <a:pPr algn="ctr">
               <a:defRPr sz="1400" b="0">
                 <a:solidFill>
-                  <a:srgbClr val="C8D0D9"/>
+                  <a:srgbClr val="FFFFFF"/>
                 </a:solidFill>
                 <a:latin typeface="Segoe UI"/>
               </a:defRPr>
             </a:pPr>
             <a:r>
-              <a:t>Loads clean data into a local 'operations.db' database.</a:t>
+              <a:t>Derives Actual vs Scheduled durations.</a:t>
             </a:r>
             <a:br/>
             <a:br/>
             <a:r>
-              <a:t>Builds B-Tree indexes on Tail Numbers and Origins to guarantee rapid downstream SQL querying.</a:t>
+              <a:t>Heuristically adjusts for complex edge-cases like overnight flight arrivals.</a:t>
+            </a:r>
+          </a:p>
+        </p:txBody>
+      </p:sp>
+      <p:sp>
+        <p:nvSpPr>
+          <p:cNvPr id="11" name="Rounded Rectangle 10"/>
+          <p:cNvSpPr/>
+          <p:nvPr/>
+        </p:nvSpPr>
+        <p:spPr>
+          <a:xfrm>
+            <a:off x="8229600" y="2286000"/>
+            <a:ext cx="2926080" cy="2743200"/>
+          </a:xfrm>
+          <a:prstGeom prst="roundRect">
+            <a:avLst/>
+          </a:prstGeom>
+          <a:solidFill>
+            <a:srgbClr val="14325A"/>
+          </a:solidFill>
+          <a:ln>
+            <a:solidFill>
+              <a:srgbClr val="00D2D3"/>
+            </a:solidFill>
+          </a:ln>
+        </p:spPr>
+        <p:style>
+          <a:lnRef idx="1">
+            <a:schemeClr val="accent1"/>
+          </a:lnRef>
+          <a:fillRef idx="3">
+            <a:schemeClr val="accent1"/>
+          </a:fillRef>
+          <a:effectRef idx="2">
+            <a:schemeClr val="accent1"/>
+          </a:effectRef>
+          <a:fontRef idx="minor">
+            <a:schemeClr val="lt1"/>
+          </a:fontRef>
+        </p:style>
+        <p:txBody>
+          <a:bodyPr rtlCol="0" anchor="ctr"/>
+          <a:lstStyle/>
+          <a:p>
+            <a:pPr algn="ctr"/>
+          </a:p>
+        </p:txBody>
+      </p:sp>
+      <p:sp>
+        <p:nvSpPr>
+          <p:cNvPr id="12" name="TextBox 11"/>
+          <p:cNvSpPr txBox="1"/>
+          <p:nvPr/>
+        </p:nvSpPr>
+        <p:spPr>
+          <a:xfrm>
+            <a:off x="8321040" y="2468880"/>
+            <a:ext cx="2743200" cy="457200"/>
+          </a:xfrm>
+          <a:prstGeom prst="rect">
+            <a:avLst/>
+          </a:prstGeom>
+          <a:noFill/>
+        </p:spPr>
+        <p:txBody>
+          <a:bodyPr wrap="square">
+            <a:spAutoFit/>
+          </a:bodyPr>
+          <a:lstStyle/>
+          <a:p>
+            <a:pPr algn="ctr">
+              <a:defRPr sz="2200" b="1">
+                <a:solidFill>
+                  <a:srgbClr val="FDA05B"/>
+                </a:solidFill>
+                <a:latin typeface="Segoe UI"/>
+              </a:defRPr>
+            </a:pPr>
+            <a:r>
+              <a:t>3. SQLite Database</a:t>
+            </a:r>
+          </a:p>
+        </p:txBody>
+      </p:sp>
+      <p:sp>
+        <p:nvSpPr>
+          <p:cNvPr id="13" name="TextBox 12"/>
+          <p:cNvSpPr txBox="1"/>
+          <p:nvPr/>
+        </p:nvSpPr>
+        <p:spPr>
+          <a:xfrm>
+            <a:off x="8321040" y="3200400"/>
+            <a:ext cx="2743200" cy="1371600"/>
+          </a:xfrm>
+          <a:prstGeom prst="rect">
+            <a:avLst/>
+          </a:prstGeom>
+          <a:noFill/>
+        </p:spPr>
+        <p:txBody>
+          <a:bodyPr wrap="square">
+            <a:spAutoFit/>
+          </a:bodyPr>
+          <a:lstStyle/>
+          <a:p>
+            <a:pPr algn="ctr">
+              <a:defRPr sz="1400" b="0">
+                <a:solidFill>
+                  <a:srgbClr val="FFFFFF"/>
+                </a:solidFill>
+                <a:latin typeface="Segoe UI"/>
+              </a:defRPr>
+            </a:pPr>
+            <a:r>
+              <a:t>Loads data into local 'operations.db'.</a:t>
+            </a:r>
+            <a:br/>
+            <a:br/>
+            <a:r>
+              <a:t>Builds B-Tree indexes on Tail Numbers to guarantee rapid downstream SQL querying.</a:t>
             </a:r>
           </a:p>
         </p:txBody>
@@ -3889,9 +4010,73 @@
         <p:nvPr/>
       </p:nvGrpSpPr>
       <p:grpSpPr/>
-      <p:sp>
-        <p:nvSpPr>
-          <p:cNvPr id="2" name="TextBox 1"/>
+      <p:pic>
+        <p:nvPicPr>
+          <p:cNvPr id="2" name="Picture 1" descr="network.jpg"/>
+          <p:cNvPicPr>
+            <a:picLocks noChangeAspect="1"/>
+          </p:cNvPicPr>
+          <p:nvPr/>
+        </p:nvPicPr>
+        <p:blipFill>
+          <a:blip r:embed="rId2"/>
+          <a:stretch>
+            <a:fillRect/>
+          </a:stretch>
+        </p:blipFill>
+        <p:spPr>
+          <a:xfrm>
+            <a:off x="0" y="0"/>
+            <a:ext cx="12191695" cy="6804667"/>
+          </a:xfrm>
+          <a:prstGeom prst="rect">
+            <a:avLst/>
+          </a:prstGeom>
+        </p:spPr>
+      </p:pic>
+      <p:sp>
+        <p:nvSpPr>
+          <p:cNvPr id="3" name="Rectangle 2"/>
+          <p:cNvSpPr/>
+          <p:nvPr/>
+        </p:nvSpPr>
+        <p:spPr>
+          <a:xfrm>
+            <a:off x="0" y="0"/>
+            <a:ext cx="12191695" cy="6858000"/>
+          </a:xfrm>
+          <a:prstGeom prst="rect">
+            <a:avLst/>
+          </a:prstGeom>
+          <a:solidFill>
+            <a:srgbClr val="050F1E"/>
+          </a:solidFill>
+        </p:spPr>
+        <p:style>
+          <a:lnRef idx="1">
+            <a:schemeClr val="accent1"/>
+          </a:lnRef>
+          <a:fillRef idx="3">
+            <a:schemeClr val="accent1"/>
+          </a:fillRef>
+          <a:effectRef idx="2">
+            <a:schemeClr val="accent1"/>
+          </a:effectRef>
+          <a:fontRef idx="minor">
+            <a:schemeClr val="lt1"/>
+          </a:fontRef>
+        </p:style>
+        <p:txBody>
+          <a:bodyPr rtlCol="0" anchor="ctr"/>
+          <a:lstStyle/>
+          <a:p>
+            <a:pPr algn="ctr"/>
+          </a:p>
+        </p:txBody>
+      </p:sp>
+      <p:sp>
+        <p:nvSpPr>
+          <p:cNvPr id="4" name="TextBox 3"/>
           <p:cNvSpPr txBox="1"/>
           <p:nvPr/>
         </p:nvSpPr>
@@ -3927,7 +4112,7 @@
       </p:sp>
       <p:sp>
         <p:nvSpPr>
-          <p:cNvPr id="3" name="TextBox 2"/>
+          <p:cNvPr id="5" name="TextBox 4"/>
           <p:cNvSpPr txBox="1"/>
           <p:nvPr/>
         </p:nvSpPr>
@@ -3949,106 +4134,93 @@
           <a:p/>
           <a:p>
             <a:pPr>
+              <a:defRPr sz="2800" b="1">
+                <a:solidFill>
+                  <a:srgbClr val="FDA05B"/>
+                </a:solidFill>
+                <a:latin typeface="Segoe UI"/>
+              </a:defRPr>
+            </a:pPr>
+            <a:r>
+              <a:t>Unlocking Network Intelligence using Window Functions</a:t>
+            </a:r>
+          </a:p>
+          <a:p>
+            <a:pPr lvl="1">
               <a:defRPr sz="2400" b="1">
                 <a:solidFill>
+                  <a:srgbClr val="00D2D3"/>
+                </a:solidFill>
+                <a:latin typeface="Segoe UI"/>
+              </a:defRPr>
+            </a:pPr>
+            <a:r>
+              <a:t>Common Table Expressions (CTEs)</a:t>
+            </a:r>
+          </a:p>
+          <a:p>
+            <a:pPr lvl="2">
+              <a:defRPr sz="2000" b="0">
+                <a:solidFill>
                   <a:srgbClr val="FFFFFF"/>
                 </a:solidFill>
                 <a:latin typeface="Segoe UI"/>
               </a:defRPr>
             </a:pPr>
             <a:r>
-              <a:t>Unlocking Network Intelligence using Advanced Window Functions</a:t>
+              <a:t>Instead of Python loops, we utilize highly optimized SQL CTEs to trace aircraft history.</a:t>
             </a:r>
           </a:p>
           <a:p>
             <a:pPr lvl="1">
-              <a:defRPr sz="2200" b="1">
-                <a:solidFill>
-                  <a:srgbClr val="FDA05B"/>
+              <a:defRPr sz="2400" b="1">
+                <a:solidFill>
+                  <a:srgbClr val="00D2D3"/>
                 </a:solidFill>
                 <a:latin typeface="Segoe UI"/>
               </a:defRPr>
             </a:pPr>
             <a:r>
-              <a:t>Common Table Expressions (CTEs)</a:t>
+              <a:t>Physical Aircraft Sequencing [ LAG() ]</a:t>
             </a:r>
           </a:p>
           <a:p>
             <a:pPr lvl="2">
-              <a:defRPr sz="1800" b="0">
-                <a:solidFill>
-                  <a:srgbClr val="C8D0D9"/>
+              <a:defRPr sz="2000" b="0">
+                <a:solidFill>
+                  <a:srgbClr val="FFFFFF"/>
                 </a:solidFill>
                 <a:latin typeface="Segoe UI"/>
               </a:defRPr>
             </a:pPr>
             <a:r>
-              <a:t>Instead of complex Python loops, we utilize highly optimized SQL CTEs to trace aircraft history.</a:t>
+              <a:t>Partitioning data by 'Tail_Number', we dynamically lookup the exact arrival time of the aircraft's prior flight.</a:t>
             </a:r>
           </a:p>
           <a:p>
             <a:pPr lvl="1">
-              <a:defRPr sz="2200" b="1">
-                <a:solidFill>
-                  <a:srgbClr val="FDA05B"/>
+              <a:defRPr sz="2400" b="1">
+                <a:solidFill>
+                  <a:srgbClr val="00D2D3"/>
                 </a:solidFill>
                 <a:latin typeface="Segoe UI"/>
               </a:defRPr>
             </a:pPr>
             <a:r>
-              <a:t>Physical Aircraft Sequencing [ LAG() ]</a:t>
+              <a:t>Isolating Network Choke Points</a:t>
             </a:r>
           </a:p>
           <a:p>
             <a:pPr lvl="2">
-              <a:defRPr sz="1800" b="0">
-                <a:solidFill>
-                  <a:srgbClr val="C8D0D9"/>
+              <a:defRPr sz="2000" b="0">
+                <a:solidFill>
+                  <a:srgbClr val="FFFFFF"/>
                 </a:solidFill>
                 <a:latin typeface="Segoe UI"/>
               </a:defRPr>
             </a:pPr>
             <a:r>
-              <a:t>By partitioning data by 'Tail_Number' and ordering by 'Scheduled_Departure', we dynamically lookup the exact arrival time and location of the aircraft's prior flight.</a:t>
-            </a:r>
-          </a:p>
-          <a:p>
-            <a:pPr lvl="2">
-              <a:defRPr sz="1800" b="0">
-                <a:solidFill>
-                  <a:srgbClr val="C8D0D9"/>
-                </a:solidFill>
-                <a:latin typeface="Segoe UI"/>
-              </a:defRPr>
-            </a:pPr>
-            <a:r>
-              <a:t>This confirms physical aircraft continuity (Prior Destination = Current Origin) to calculate true ground turnaround metrics.</a:t>
-            </a:r>
-          </a:p>
-          <a:p>
-            <a:pPr lvl="1">
-              <a:defRPr sz="2200" b="1">
-                <a:solidFill>
-                  <a:srgbClr val="FDA05B"/>
-                </a:solidFill>
-                <a:latin typeface="Segoe UI"/>
-              </a:defRPr>
-            </a:pPr>
-            <a:r>
-              <a:t>Isolating Network Choke Points</a:t>
-            </a:r>
-          </a:p>
-          <a:p>
-            <a:pPr lvl="2">
-              <a:defRPr sz="1800" b="0">
-                <a:solidFill>
-                  <a:srgbClr val="C8D0D9"/>
-                </a:solidFill>
-                <a:latin typeface="Segoe UI"/>
-              </a:defRPr>
-            </a:pPr>
-            <a:r>
-              <a:t>We aggregate these metrics by Airport and Carrier, flagging flights where an inbound delay directly triggered an outbound delay, effectively creating a map of operational choke points.</a:t>
+              <a:t>We aggregate these metrics by Airport and Carrier, flagging cascading delay choke points.</a:t>
             </a:r>
           </a:p>
         </p:txBody>
@@ -4079,9 +4251,33 @@
         <p:nvPr/>
       </p:nvGrpSpPr>
       <p:grpSpPr/>
-      <p:sp>
-        <p:nvSpPr>
-          <p:cNvPr id="2" name="TextBox 1"/>
+      <p:pic>
+        <p:nvPicPr>
+          <p:cNvPr id="2" name="Picture 1" descr="network.jpg"/>
+          <p:cNvPicPr>
+            <a:picLocks noChangeAspect="1"/>
+          </p:cNvPicPr>
+          <p:nvPr/>
+        </p:nvPicPr>
+        <p:blipFill>
+          <a:blip r:embed="rId2"/>
+          <a:stretch>
+            <a:fillRect/>
+          </a:stretch>
+        </p:blipFill>
+        <p:spPr>
+          <a:xfrm>
+            <a:off x="7315200" y="0"/>
+            <a:ext cx="12287250" cy="6858000"/>
+          </a:xfrm>
+          <a:prstGeom prst="rect">
+            <a:avLst/>
+          </a:prstGeom>
+        </p:spPr>
+      </p:pic>
+      <p:sp>
+        <p:nvSpPr>
+          <p:cNvPr id="3" name="TextBox 2"/>
           <p:cNvSpPr txBox="1"/>
           <p:nvPr/>
         </p:nvSpPr>
@@ -4110,21 +4306,21 @@
               </a:defRPr>
             </a:pPr>
             <a:r>
-              <a:t>Phase 3: Machine Learning &amp; Prediction</a:t>
-            </a:r>
-          </a:p>
-        </p:txBody>
-      </p:sp>
-      <p:sp>
-        <p:nvSpPr>
-          <p:cNvPr id="3" name="TextBox 2"/>
+              <a:t>Phase 3: Machine Learning Prediction</a:t>
+            </a:r>
+          </a:p>
+        </p:txBody>
+      </p:sp>
+      <p:sp>
+        <p:nvSpPr>
+          <p:cNvPr id="4" name="TextBox 3"/>
           <p:cNvSpPr txBox="1"/>
           <p:nvPr/>
         </p:nvSpPr>
         <p:spPr>
           <a:xfrm>
             <a:off x="731520" y="1645920"/>
-            <a:ext cx="5486400" cy="4572000"/>
+            <a:ext cx="5943600" cy="4572000"/>
           </a:xfrm>
           <a:prstGeom prst="rect">
             <a:avLst/>
@@ -4139,7 +4335,7 @@
           <a:p/>
           <a:p>
             <a:pPr>
-              <a:defRPr sz="2400" b="1">
+              <a:defRPr sz="2800" b="1">
                 <a:solidFill>
                   <a:srgbClr val="FDA05B"/>
                 </a:solidFill>
@@ -4147,7 +4343,7 @@
               </a:defRPr>
             </a:pPr>
             <a:r>
-              <a:t>The Goal</a:t>
+              <a:t>The Predictive Engine</a:t>
             </a:r>
           </a:p>
           <a:p>
@@ -4160,12 +4356,12 @@
               </a:defRPr>
             </a:pPr>
             <a:r>
-              <a:t>Predict if a flight will breach its turnaround buffer and cause severe downstream delays.</a:t>
+              <a:t>Predict if a flight will breach its turnaround buffer.</a:t>
             </a:r>
           </a:p>
           <a:p>
             <a:pPr>
-              <a:defRPr sz="2400" b="1">
+              <a:defRPr sz="2800" b="1">
                 <a:solidFill>
                   <a:srgbClr val="FDA05B"/>
                 </a:solidFill>
@@ -4178,7 +4374,7 @@
           </a:p>
           <a:p>
             <a:pPr lvl="1">
-              <a:defRPr sz="1600" b="0">
+              <a:defRPr sz="2000" b="0">
                 <a:solidFill>
                   <a:srgbClr val="FFFFFF"/>
                 </a:solidFill>
@@ -4186,12 +4382,12 @@
               </a:defRPr>
             </a:pPr>
             <a:r>
-              <a:t>Turn Buffer Volume (Mins)</a:t>
+              <a:t>Turn Buffer Volume</a:t>
             </a:r>
           </a:p>
           <a:p>
             <a:pPr lvl="1">
-              <a:defRPr sz="1600" b="0">
+              <a:defRPr sz="2000" b="0">
                 <a:solidFill>
                   <a:srgbClr val="FFFFFF"/>
                 </a:solidFill>
@@ -4204,7 +4400,7 @@
           </a:p>
           <a:p>
             <a:pPr lvl="1">
-              <a:defRPr sz="1600" b="0">
+              <a:defRPr sz="2000" b="0">
                 <a:solidFill>
                   <a:srgbClr val="FFFFFF"/>
                 </a:solidFill>
@@ -4216,29 +4412,16 @@
             </a:r>
           </a:p>
           <a:p>
-            <a:pPr lvl="1">
-              <a:defRPr sz="1600" b="0">
-                <a:solidFill>
-                  <a:srgbClr val="FFFFFF"/>
+            <a:pPr>
+              <a:defRPr sz="2800" b="1">
+                <a:solidFill>
+                  <a:srgbClr val="FDA05B"/>
                 </a:solidFill>
                 <a:latin typeface="Segoe UI"/>
               </a:defRPr>
             </a:pPr>
             <a:r>
-              <a:t>Tail-Number Historical Delay Frequencies</a:t>
-            </a:r>
-          </a:p>
-          <a:p>
-            <a:pPr>
-              <a:defRPr sz="2400" b="1">
-                <a:solidFill>
-                  <a:srgbClr val="FDA05B"/>
-                </a:solidFill>
-                <a:latin typeface="Segoe UI"/>
-              </a:defRPr>
-            </a:pPr>
-            <a:r>
-              <a:t>The Algorithm</a:t>
+              <a:t>Random Forest Classifier</a:t>
             </a:r>
           </a:p>
           <a:p>
@@ -4251,142 +4434,7 @@
               </a:defRPr>
             </a:pPr>
             <a:r>
-              <a:t>Random Forest Classifier. We explicitly combat dataset class-imbalance by utilizing computationally balanced class weights.</a:t>
-            </a:r>
-          </a:p>
-        </p:txBody>
-      </p:sp>
-      <p:sp>
-        <p:nvSpPr>
-          <p:cNvPr id="4" name="Rounded Rectangle 3"/>
-          <p:cNvSpPr/>
-          <p:nvPr/>
-        </p:nvSpPr>
-        <p:spPr>
-          <a:xfrm>
-            <a:off x="6858000" y="1828800"/>
-            <a:ext cx="4572000" cy="3657600"/>
-          </a:xfrm>
-          <a:prstGeom prst="roundRect">
-            <a:avLst/>
-          </a:prstGeom>
-          <a:solidFill>
-            <a:srgbClr val="14325A"/>
-          </a:solidFill>
-          <a:ln>
-            <a:solidFill>
-              <a:srgbClr val="00D2D3"/>
-            </a:solidFill>
-          </a:ln>
-        </p:spPr>
-        <p:style>
-          <a:lnRef idx="1">
-            <a:schemeClr val="accent1"/>
-          </a:lnRef>
-          <a:fillRef idx="3">
-            <a:schemeClr val="accent1"/>
-          </a:fillRef>
-          <a:effectRef idx="2">
-            <a:schemeClr val="accent1"/>
-          </a:effectRef>
-          <a:fontRef idx="minor">
-            <a:schemeClr val="lt1"/>
-          </a:fontRef>
-        </p:style>
-        <p:txBody>
-          <a:bodyPr rtlCol="0" anchor="ctr"/>
-          <a:lstStyle/>
-          <a:p>
-            <a:pPr algn="ctr"/>
-          </a:p>
-        </p:txBody>
-      </p:sp>
-      <p:sp>
-        <p:nvSpPr>
-          <p:cNvPr id="5" name="TextBox 4"/>
-          <p:cNvSpPr txBox="1"/>
-          <p:nvPr/>
-        </p:nvSpPr>
-        <p:spPr>
-          <a:xfrm>
-            <a:off x="6858000" y="2011680"/>
-            <a:ext cx="4572000" cy="457200"/>
-          </a:xfrm>
-          <a:prstGeom prst="rect">
-            <a:avLst/>
-          </a:prstGeom>
-          <a:noFill/>
-        </p:spPr>
-        <p:txBody>
-          <a:bodyPr wrap="square">
-            <a:spAutoFit/>
-          </a:bodyPr>
-          <a:lstStyle/>
-          <a:p>
-            <a:pPr algn="ctr">
-              <a:defRPr sz="2800" b="1">
-                <a:solidFill>
-                  <a:srgbClr val="FDA05B"/>
-                </a:solidFill>
-                <a:latin typeface="Segoe UI"/>
-              </a:defRPr>
-            </a:pPr>
-            <a:r>
-              <a:t>Model Performance</a:t>
-            </a:r>
-          </a:p>
-        </p:txBody>
-      </p:sp>
-      <p:sp>
-        <p:nvSpPr>
-          <p:cNvPr id="6" name="TextBox 5"/>
-          <p:cNvSpPr txBox="1"/>
-          <p:nvPr/>
-        </p:nvSpPr>
-        <p:spPr>
-          <a:xfrm>
-            <a:off x="7132320" y="2743200"/>
-            <a:ext cx="4023360" cy="2286000"/>
-          </a:xfrm>
-          <a:prstGeom prst="rect">
-            <a:avLst/>
-          </a:prstGeom>
-          <a:noFill/>
-        </p:spPr>
-        <p:txBody>
-          <a:bodyPr wrap="square">
-            <a:spAutoFit/>
-          </a:bodyPr>
-          <a:lstStyle/>
-          <a:p>
-            <a:pPr algn="l">
-              <a:defRPr sz="2000" b="0">
-                <a:solidFill>
-                  <a:srgbClr val="FFFFFF"/>
-                </a:solidFill>
-                <a:latin typeface="Segoe UI"/>
-              </a:defRPr>
-            </a:pPr>
-            <a:r>
-              <a:t>PR-AUC Score: 0.82</a:t>
-            </a:r>
-            <a:br/>
-            <a:br/>
-            <a:r>
-              <a:t>Precision: 78.4%</a:t>
-            </a:r>
-            <a:br/>
-            <a:r>
-              <a:t>(High accuracy when flagging delays)</a:t>
-            </a:r>
-            <a:br/>
-            <a:br/>
-            <a:r>
-              <a:t>Recall: 65.9%</a:t>
-            </a:r>
-            <a:br/>
-            <a:r>
-              <a:t>(Caught 66% of all actual delays)</a:t>
+              <a:t>Explicitly combats class-imbalance utilizing computationally balanced class weights.</a:t>
             </a:r>
           </a:p>
         </p:txBody>
@@ -4491,20 +4539,20 @@
       </p:sp>
       <p:sp>
         <p:nvSpPr>
-          <p:cNvPr id="4" name="Rectangle 3"/>
+          <p:cNvPr id="4" name="Rounded Rectangle 3"/>
           <p:cNvSpPr/>
           <p:nvPr/>
         </p:nvSpPr>
         <p:spPr>
           <a:xfrm>
             <a:off x="1371600" y="2560320"/>
-            <a:ext cx="4114800" cy="2286000"/>
-          </a:xfrm>
-          <a:prstGeom prst="rect">
+            <a:ext cx="4114800" cy="2743200"/>
+          </a:xfrm>
+          <a:prstGeom prst="roundRect">
             <a:avLst/>
           </a:prstGeom>
           <a:solidFill>
-            <a:srgbClr val="281414"/>
+            <a:srgbClr val="3C1414"/>
           </a:solidFill>
           <a:ln>
             <a:solidFill>
@@ -4559,7 +4607,7 @@
             <a:pPr algn="ctr">
               <a:defRPr sz="2200" b="0">
                 <a:solidFill>
-                  <a:srgbClr val="C8D0D9"/>
+                  <a:srgbClr val="FFFFFF"/>
                 </a:solidFill>
                 <a:latin typeface="Segoe UI"/>
               </a:defRPr>
@@ -4593,7 +4641,7 @@
           <a:lstStyle/>
           <a:p>
             <a:pPr algn="ctr">
-              <a:defRPr sz="4400" b="1">
+              <a:defRPr sz="5400" b="1">
                 <a:solidFill>
                   <a:srgbClr val="FF6464"/>
                 </a:solidFill>
@@ -4601,27 +4649,63 @@
               </a:defRPr>
             </a:pPr>
             <a:r>
-              <a:t>$51.2 Million</a:t>
-            </a:r>
-          </a:p>
-        </p:txBody>
-      </p:sp>
-      <p:sp>
-        <p:nvSpPr>
-          <p:cNvPr id="7" name="Rectangle 6"/>
-          <p:cNvSpPr/>
+              <a:t>$51.2 M</a:t>
+            </a:r>
+          </a:p>
+        </p:txBody>
+      </p:sp>
+      <p:sp>
+        <p:nvSpPr>
+          <p:cNvPr id="7" name="TextBox 6"/>
+          <p:cNvSpPr txBox="1"/>
           <p:nvPr/>
         </p:nvSpPr>
         <p:spPr>
           <a:xfrm>
-            <a:off x="6675120" y="2560320"/>
-            <a:ext cx="4114800" cy="2286000"/>
+            <a:off x="1371600" y="4389120"/>
+            <a:ext cx="4114800" cy="457200"/>
           </a:xfrm>
           <a:prstGeom prst="rect">
             <a:avLst/>
           </a:prstGeom>
+          <a:noFill/>
+        </p:spPr>
+        <p:txBody>
+          <a:bodyPr wrap="square">
+            <a:spAutoFit/>
+          </a:bodyPr>
+          <a:lstStyle/>
+          <a:p>
+            <a:pPr algn="ctr">
+              <a:defRPr sz="1600" b="0">
+                <a:solidFill>
+                  <a:srgbClr val="C8D0D9"/>
+                </a:solidFill>
+                <a:latin typeface="Segoe UI"/>
+              </a:defRPr>
+            </a:pPr>
+            <a:r>
+              <a:t>FAA Benchmark: $75 / min</a:t>
+            </a:r>
+          </a:p>
+        </p:txBody>
+      </p:sp>
+      <p:sp>
+        <p:nvSpPr>
+          <p:cNvPr id="8" name="Rounded Rectangle 7"/>
+          <p:cNvSpPr/>
+          <p:nvPr/>
+        </p:nvSpPr>
+        <p:spPr>
+          <a:xfrm>
+            <a:off x="6675120" y="2560320"/>
+            <a:ext cx="4114800" cy="2743200"/>
+          </a:xfrm>
+          <a:prstGeom prst="roundRect">
+            <a:avLst/>
+          </a:prstGeom>
           <a:solidFill>
-            <a:srgbClr val="142814"/>
+            <a:srgbClr val="143C14"/>
           </a:solidFill>
           <a:ln>
             <a:solidFill>
@@ -4653,7 +4737,7 @@
       </p:sp>
       <p:sp>
         <p:nvSpPr>
-          <p:cNvPr id="8" name="TextBox 7"/>
+          <p:cNvPr id="9" name="TextBox 8"/>
           <p:cNvSpPr txBox="1"/>
           <p:nvPr/>
         </p:nvSpPr>
@@ -4676,7 +4760,7 @@
             <a:pPr algn="ctr">
               <a:defRPr sz="2200" b="0">
                 <a:solidFill>
-                  <a:srgbClr val="C8D0D9"/>
+                  <a:srgbClr val="FFFFFF"/>
                 </a:solidFill>
                 <a:latin typeface="Segoe UI"/>
               </a:defRPr>
@@ -4689,7 +4773,7 @@
       </p:sp>
       <p:sp>
         <p:nvSpPr>
-          <p:cNvPr id="9" name="TextBox 8"/>
+          <p:cNvPr id="10" name="TextBox 9"/>
           <p:cNvSpPr txBox="1"/>
           <p:nvPr/>
         </p:nvSpPr>
@@ -4710,7 +4794,7 @@
           <a:lstStyle/>
           <a:p>
             <a:pPr algn="ctr">
-              <a:defRPr sz="4400" b="1">
+              <a:defRPr sz="5400" b="1">
                 <a:solidFill>
                   <a:srgbClr val="64FF64"/>
                 </a:solidFill>
@@ -4718,14 +4802,14 @@
               </a:defRPr>
             </a:pPr>
             <a:r>
-              <a:t>$10.2 Million</a:t>
-            </a:r>
-          </a:p>
-        </p:txBody>
-      </p:sp>
-      <p:sp>
-        <p:nvSpPr>
-          <p:cNvPr id="10" name="TextBox 9"/>
+              <a:t>$10.2 M</a:t>
+            </a:r>
+          </a:p>
+        </p:txBody>
+      </p:sp>
+      <p:sp>
+        <p:nvSpPr>
+          <p:cNvPr id="11" name="TextBox 10"/>
           <p:cNvSpPr txBox="1"/>
           <p:nvPr/>
         </p:nvSpPr>
@@ -4746,7 +4830,7 @@
           <a:lstStyle/>
           <a:p>
             <a:pPr algn="ctr">
-              <a:defRPr sz="1400" b="0">
+              <a:defRPr sz="1600" b="0">
                 <a:solidFill>
                   <a:srgbClr val="C8D0D9"/>
                 </a:solidFill>

</xml_diff>

<commit_message>
feat: Add 6-slide presentation deck and 4m15s full 1080p narrated walkthrough video with AI voiceover
</commit_message>
<xml_diff>
--- a/Workflow_Presentation.pptx
+++ b/Workflow_Presentation.pptx
@@ -11,8 +11,6 @@
     <p:sldId id="259" r:id="rId10"/>
     <p:sldId id="260" r:id="rId11"/>
     <p:sldId id="261" r:id="rId12"/>
-    <p:sldId id="262" r:id="rId13"/>
-    <p:sldId id="263" r:id="rId14"/>
   </p:sldIdLst>
   <p:sldSz cx="12191695" cy="6858000" type="screen4x3"/>
   <p:notesSz cx="6858000" cy="9144000"/>
@@ -3211,7 +3209,7 @@
               </a:defRPr>
             </a:pPr>
             <a:r>
-              <a:t>ENTERPRISE FLEET ANALYTICS // FLIGHT OPERATIONS CONTROL CENTER</a:t>
+              <a:t>ENTERPRISE FLEET ANALYTICS // OPERATIONS CONTROL CENTER DECISION SUPPORT</a:t>
             </a:r>
           </a:p>
           <a:p>
@@ -3536,7 +3534,7 @@
               </a:defRPr>
             </a:pPr>
             <a:r>
-              <a:t>Turnarounds Analyzed</a:t>
+              <a:t>Turnarounds Modeled</a:t>
             </a:r>
           </a:p>
           <a:p>
@@ -3689,7 +3687,7 @@
               </a:defRPr>
             </a:pPr>
             <a:r>
-              <a:t>PR-AUC Classification</a:t>
+              <a:t>PR-AUC Accuracy</a:t>
             </a:r>
           </a:p>
           <a:p>
@@ -4031,7 +4029,7 @@
               </a:defRPr>
             </a:pPr>
             <a:r>
-              <a:t>PHASE 01 // THE OPERATIONAL BOTTLENECK</a:t>
+              <a:t>SLIDE 02 // OPERATIONAL PROBLEM</a:t>
             </a:r>
           </a:p>
           <a:p>
@@ -4061,7 +4059,7 @@
               </a:defRPr>
             </a:pPr>
             <a:r>
-              <a:t>Airlines operate on hyper-compressed turnaround windows; when ground buffers fail, delays compound exponentially.</a:t>
+              <a:t>Airlines operate on hyper-compressed turnaround schedules; when ground buffers fail, delays compound exponentially.</a:t>
             </a:r>
           </a:p>
         </p:txBody>
@@ -4141,7 +4139,7 @@
               </a:defRPr>
             </a:pPr>
             <a:r>
-              <a:t>1. The Scheduled Turn Buffer</a:t>
+              <a:t>1. Scheduled Turn Buffer</a:t>
             </a:r>
           </a:p>
         </p:txBody>
@@ -4187,7 +4185,7 @@
                   <a:srgbClr val="94A3B8"/>
                 </a:solidFill>
               </a:rPr>
-              <a:t>A scheduled 45-60 minute window allocated at the gate for simultaneous deplaning, baggage unloading, fueling, cleaning, catering, and passenger boarding.</a:t>
+              <a:t>A scheduled 45-60 minute window allocated at the gate for simultaneous deplaning, fueling, cleaning, catering, and boarding.</a:t>
             </a:r>
           </a:p>
           <a:p>
@@ -4716,7 +4714,7 @@
               </a:defRPr>
             </a:pPr>
             <a:r>
-              <a:t>PHASE 02 // ENGINEERING ARCHITECTURE</a:t>
+              <a:t>SLIDE 03 // SYSTEM ARCHITECTURE</a:t>
             </a:r>
           </a:p>
           <a:p>
@@ -4731,7 +4729,7 @@
               </a:defRPr>
             </a:pPr>
             <a:r>
-              <a:t>End-to-End Four-Stage Optimization Pipeline</a:t>
+              <a:t>End-to-End Decoupled Engineering Architecture</a:t>
             </a:r>
           </a:p>
           <a:p>
@@ -4746,7 +4744,7 @@
               </a:defRPr>
             </a:pPr>
             <a:r>
-              <a:t>Decoupled, high-throughput pipeline moving from raw BTS aviation records to predictive dispatch intelligence.</a:t>
+              <a:t>A modular, high-throughput pipeline moving from raw BTS aviation records to predictive dispatch intelligence.</a:t>
             </a:r>
           </a:p>
         </p:txBody>
@@ -4760,7 +4758,7 @@
         <p:spPr>
           <a:xfrm>
             <a:off x="731520" y="1645920"/>
-            <a:ext cx="2514600" cy="4663440"/>
+            <a:ext cx="3364992" cy="4663440"/>
           </a:xfrm>
           <a:prstGeom prst="roundRect">
             <a:avLst/>
@@ -4805,7 +4803,7 @@
         <p:spPr>
           <a:xfrm>
             <a:off x="914400" y="1828800"/>
-            <a:ext cx="2148840" cy="822960"/>
+            <a:ext cx="2999232" cy="822960"/>
           </a:xfrm>
           <a:prstGeom prst="rect">
             <a:avLst/>
@@ -4826,7 +4824,7 @@
               </a:defRPr>
             </a:pPr>
             <a:r>
-              <a:t>STAGE 01</a:t>
+              <a:t>PIPELINE 01</a:t>
             </a:r>
           </a:p>
           <a:p>
@@ -4870,7 +4868,7 @@
         <p:spPr>
           <a:xfrm>
             <a:off x="914400" y="2834640"/>
-            <a:ext cx="2148840" cy="3383280"/>
+            <a:ext cx="2999232" cy="3383280"/>
           </a:xfrm>
           <a:prstGeom prst="rect">
             <a:avLst/>
@@ -4894,7 +4892,7 @@
               </a:defRPr>
             </a:pPr>
             <a:r>
-              <a:t>• BTS Raw Datasets</a:t>
+              <a:t>• BTS Raw Telemetry</a:t>
             </a:r>
           </a:p>
           <a:p>
@@ -4909,7 +4907,7 @@
               </a:defRPr>
             </a:pPr>
             <a:r>
-              <a:t>Ingests 244MB DOT BTS carrier performance CSVs containing 440k+ flight records.</a:t>
+              <a:t>Ingests 244MB DOT BTS carrier performance datasets comprising 441,348 flight records.</a:t>
             </a:r>
           </a:p>
           <a:p>
@@ -4924,7 +4922,7 @@
               </a:defRPr>
             </a:pPr>
             <a:r>
-              <a:t>• Overnight Heuristics</a:t>
+              <a:t>• Midnight Rollover Heuristics</a:t>
             </a:r>
           </a:p>
           <a:p>
@@ -4939,7 +4937,7 @@
               </a:defRPr>
             </a:pPr>
             <a:r>
-              <a:t>Resolves midnight clock rollovers (2400 to 0000) and multi-day arrival adjustments.</a:t>
+              <a:t>Resolves 2400-to-0000 clock transitions and overnight cross-midnight arrivals.</a:t>
             </a:r>
           </a:p>
           <a:p>
@@ -4969,7 +4967,7 @@
               </a:defRPr>
             </a:pPr>
             <a:r>
-              <a:t>Builds B-Tree compound indexes on (Tail_Number, Scheduled_Departure) for sub-second queries.</a:t>
+              <a:t>Creates high-throughput WAL-mode database with B-Tree indexes on (Tail_Number, Scheduled_Departure).</a:t>
             </a:r>
           </a:p>
         </p:txBody>
@@ -4982,8 +4980,8 @@
         </p:nvSpPr>
         <p:spPr>
           <a:xfrm>
-            <a:off x="3465576" y="1645920"/>
-            <a:ext cx="2514600" cy="4663440"/>
+            <a:off x="4407408" y="1645920"/>
+            <a:ext cx="3364992" cy="4663440"/>
           </a:xfrm>
           <a:prstGeom prst="roundRect">
             <a:avLst/>
@@ -5027,8 +5025,8 @@
         </p:nvSpPr>
         <p:spPr>
           <a:xfrm>
-            <a:off x="3648456" y="1828800"/>
-            <a:ext cx="2148840" cy="822960"/>
+            <a:off x="4590288" y="1828800"/>
+            <a:ext cx="2999232" cy="822960"/>
           </a:xfrm>
           <a:prstGeom prst="rect">
             <a:avLst/>
@@ -5049,7 +5047,7 @@
               </a:defRPr>
             </a:pPr>
             <a:r>
-              <a:t>STAGE 02</a:t>
+              <a:t>PIPELINE 02</a:t>
             </a:r>
           </a:p>
           <a:p>
@@ -5092,8 +5090,8 @@
         </p:nvSpPr>
         <p:spPr>
           <a:xfrm>
-            <a:off x="3648456" y="2834640"/>
-            <a:ext cx="2148840" cy="3383280"/>
+            <a:off x="4590288" y="2834640"/>
+            <a:ext cx="2999232" cy="3383280"/>
           </a:xfrm>
           <a:prstGeom prst="rect">
             <a:avLst/>
@@ -5117,7 +5115,7 @@
               </a:defRPr>
             </a:pPr>
             <a:r>
-              <a:t>• Physical Tail Tracking</a:t>
+              <a:t>• Aircraft LAG() Windowing</a:t>
             </a:r>
           </a:p>
           <a:p>
@@ -5132,7 +5130,7 @@
               </a:defRPr>
             </a:pPr>
             <a:r>
-              <a:t>Executes LAG() window functions partitioned by aircraft tail to trace prior arrivals.</a:t>
+              <a:t>Sequences flights by physical aircraft tail number to capture prior arrival timestamps.</a:t>
             </a:r>
           </a:p>
           <a:p>
@@ -5147,7 +5145,7 @@
               </a:defRPr>
             </a:pPr>
             <a:r>
-              <a:t>• Continuity Verification</a:t>
+              <a:t>• Continuity Validation</a:t>
             </a:r>
           </a:p>
           <a:p>
@@ -5162,7 +5160,7 @@
               </a:defRPr>
             </a:pPr>
             <a:r>
-              <a:t>Enforces Prior_Dest = Current_Origin to ensure aircraft physical continuity.</a:t>
+              <a:t>Enforces Prior_Dest = Current_Origin to ensure legitimate aircraft rotation legs.</a:t>
             </a:r>
           </a:p>
           <a:p>
@@ -5192,7 +5190,7 @@
               </a:defRPr>
             </a:pPr>
             <a:r>
-              <a:t>Quantifies cascading delay rates across airport hubs to isolate network bottlenecks.</a:t>
+              <a:t>Quantifies cascading delay rates by airport hub and airline to isolate operational bottlenecks.</a:t>
             </a:r>
           </a:p>
         </p:txBody>
@@ -5205,8 +5203,8 @@
         </p:nvSpPr>
         <p:spPr>
           <a:xfrm>
-            <a:off x="6199632" y="1645920"/>
-            <a:ext cx="2514600" cy="4663440"/>
+            <a:off x="8083296" y="1645920"/>
+            <a:ext cx="3364992" cy="4663440"/>
           </a:xfrm>
           <a:prstGeom prst="roundRect">
             <a:avLst/>
@@ -5250,8 +5248,8 @@
         </p:nvSpPr>
         <p:spPr>
           <a:xfrm>
-            <a:off x="6382512" y="1828800"/>
-            <a:ext cx="2148840" cy="822960"/>
+            <a:off x="8266176" y="1828800"/>
+            <a:ext cx="2999232" cy="822960"/>
           </a:xfrm>
           <a:prstGeom prst="rect">
             <a:avLst/>
@@ -5267,12 +5265,12 @@
             <a:pPr>
               <a:defRPr sz="1100" b="1">
                 <a:solidFill>
-                  <a:srgbClr val="F59E0B"/>
-                </a:solidFill>
-              </a:defRPr>
-            </a:pPr>
-            <a:r>
-              <a:t>STAGE 03</a:t>
+                  <a:srgbClr val="10B981"/>
+                </a:solidFill>
+              </a:defRPr>
+            </a:pPr>
+            <a:r>
+              <a:t>PIPELINE 03</a:t>
             </a:r>
           </a:p>
           <a:p>
@@ -5287,7 +5285,7 @@
               </a:defRPr>
             </a:pPr>
             <a:r>
-              <a:t>Predictive ML Engine</a:t>
+              <a:t>Predictive ML &amp; Decision Support</a:t>
             </a:r>
           </a:p>
           <a:p>
@@ -5315,8 +5313,8 @@
         </p:nvSpPr>
         <p:spPr>
           <a:xfrm>
-            <a:off x="6382512" y="2834640"/>
-            <a:ext cx="2148840" cy="3383280"/>
+            <a:off x="8266176" y="2834640"/>
+            <a:ext cx="2999232" cy="3383280"/>
           </a:xfrm>
           <a:prstGeom prst="rect">
             <a:avLst/>
@@ -5355,7 +5353,7 @@
               </a:defRPr>
             </a:pPr>
             <a:r>
-              <a:t>Constructs turnaround buffer slack, inbound delay stress, and route congestion metrics.</a:t>
+              <a:t>Constructs inbound delay stress, turnaround buffer slack, and rolling route congestion signals.</a:t>
             </a:r>
           </a:p>
           <a:p>
@@ -5370,7 +5368,7 @@
               </a:defRPr>
             </a:pPr>
             <a:r>
-              <a:t>• Class-Imbalance Handling</a:t>
+              <a:t>• Class-Balanced Classifier</a:t>
             </a:r>
           </a:p>
           <a:p>
@@ -5385,7 +5383,7 @@
               </a:defRPr>
             </a:pPr>
             <a:r>
-              <a:t>Configures balanced class weights to eliminate false-negative operational bias.</a:t>
+              <a:t>Employs Random Forest with balanced class weights to eliminate false-negative operational bias.</a:t>
             </a:r>
           </a:p>
           <a:p>
@@ -5400,7 +5398,7 @@
               </a:defRPr>
             </a:pPr>
             <a:r>
-              <a:t>• Validation Scorecard</a:t>
+              <a:t>• Quantified Financial ROI</a:t>
             </a:r>
           </a:p>
           <a:p>
@@ -5415,230 +5413,7 @@
               </a:defRPr>
             </a:pPr>
             <a:r>
-              <a:t>Delivers 81.92% PR-AUC and 78.44% precision across 88,270 out-of-sample flights.</a:t>
-            </a:r>
-          </a:p>
-        </p:txBody>
-      </p:sp>
-      <p:sp>
-        <p:nvSpPr>
-          <p:cNvPr id="14" name="Rounded Rectangle 13"/>
-          <p:cNvSpPr/>
-          <p:nvPr/>
-        </p:nvSpPr>
-        <p:spPr>
-          <a:xfrm>
-            <a:off x="8933688" y="1645920"/>
-            <a:ext cx="2514600" cy="4663440"/>
-          </a:xfrm>
-          <a:prstGeom prst="roundRect">
-            <a:avLst/>
-          </a:prstGeom>
-          <a:solidFill>
-            <a:srgbClr val="182132"/>
-          </a:solidFill>
-          <a:ln w="12700">
-            <a:solidFill>
-              <a:srgbClr val="2D3C55"/>
-            </a:solidFill>
-          </a:ln>
-        </p:spPr>
-        <p:style>
-          <a:lnRef idx="1">
-            <a:schemeClr val="accent1"/>
-          </a:lnRef>
-          <a:fillRef idx="3">
-            <a:schemeClr val="accent1"/>
-          </a:fillRef>
-          <a:effectRef idx="2">
-            <a:schemeClr val="accent1"/>
-          </a:effectRef>
-          <a:fontRef idx="minor">
-            <a:schemeClr val="lt1"/>
-          </a:fontRef>
-        </p:style>
-        <p:txBody>
-          <a:bodyPr rtlCol="0" anchor="ctr"/>
-          <a:lstStyle/>
-          <a:p>
-            <a:pPr algn="ctr"/>
-          </a:p>
-        </p:txBody>
-      </p:sp>
-      <p:sp>
-        <p:nvSpPr>
-          <p:cNvPr id="15" name="TextBox 14"/>
-          <p:cNvSpPr txBox="1"/>
-          <p:nvPr/>
-        </p:nvSpPr>
-        <p:spPr>
-          <a:xfrm>
-            <a:off x="9116568" y="1828800"/>
-            <a:ext cx="2148840" cy="822960"/>
-          </a:xfrm>
-          <a:prstGeom prst="rect">
-            <a:avLst/>
-          </a:prstGeom>
-          <a:noFill/>
-        </p:spPr>
-        <p:txBody>
-          <a:bodyPr wrap="square">
-            <a:spAutoFit/>
-          </a:bodyPr>
-          <a:lstStyle/>
-          <a:p>
-            <a:pPr>
-              <a:defRPr sz="1100" b="1">
-                <a:solidFill>
-                  <a:srgbClr val="10B981"/>
-                </a:solidFill>
-              </a:defRPr>
-            </a:pPr>
-            <a:r>
-              <a:t>STAGE 04</a:t>
-            </a:r>
-          </a:p>
-          <a:p>
-            <a:pPr>
-              <a:spcBef>
-                <a:spcPts val="200"/>
-              </a:spcBef>
-              <a:defRPr sz="1300" b="1">
-                <a:solidFill>
-                  <a:srgbClr val="F8FAFC"/>
-                </a:solidFill>
-              </a:defRPr>
-            </a:pPr>
-            <a:r>
-              <a:t>Dispatch &amp; ROI Translation</a:t>
-            </a:r>
-          </a:p>
-          <a:p>
-            <a:pPr>
-              <a:spcBef>
-                <a:spcPts val="200"/>
-              </a:spcBef>
-              <a:defRPr sz="1000">
-                <a:solidFill>
-                  <a:srgbClr val="94A3B8"/>
-                </a:solidFill>
-              </a:defRPr>
-            </a:pPr>
-            <a:r>
-              <a:t>Executive Decision Support</a:t>
-            </a:r>
-          </a:p>
-        </p:txBody>
-      </p:sp>
-      <p:sp>
-        <p:nvSpPr>
-          <p:cNvPr id="16" name="TextBox 15"/>
-          <p:cNvSpPr txBox="1"/>
-          <p:nvPr/>
-        </p:nvSpPr>
-        <p:spPr>
-          <a:xfrm>
-            <a:off x="9116568" y="2834640"/>
-            <a:ext cx="2148840" cy="3383280"/>
-          </a:xfrm>
-          <a:prstGeom prst="rect">
-            <a:avLst/>
-          </a:prstGeom>
-          <a:noFill/>
-        </p:spPr>
-        <p:txBody>
-          <a:bodyPr wrap="square">
-            <a:spAutoFit/>
-          </a:bodyPr>
-          <a:lstStyle/>
-          <a:p>
-            <a:pPr>
-              <a:spcBef>
-                <a:spcPts val="800"/>
-              </a:spcBef>
-              <a:defRPr b="1" sz="1100">
-                <a:solidFill>
-                  <a:srgbClr val="F8FAFC"/>
-                </a:solidFill>
-              </a:defRPr>
-            </a:pPr>
-            <a:r>
-              <a:t>• Turn Breach Probabilities</a:t>
-            </a:r>
-          </a:p>
-          <a:p>
-            <a:pPr>
-              <a:spcBef>
-                <a:spcPts val="200"/>
-              </a:spcBef>
-              <a:defRPr sz="1000">
-                <a:solidFill>
-                  <a:srgbClr val="94A3B8"/>
-                </a:solidFill>
-              </a:defRPr>
-            </a:pPr>
-            <a:r>
-              <a:t>Generates real-time risk scores 60-90 minutes prior to touchdown.</a:t>
-            </a:r>
-          </a:p>
-          <a:p>
-            <a:pPr>
-              <a:spcBef>
-                <a:spcPts val="800"/>
-              </a:spcBef>
-              <a:defRPr b="1" sz="1100">
-                <a:solidFill>
-                  <a:srgbClr val="F8FAFC"/>
-                </a:solidFill>
-              </a:defRPr>
-            </a:pPr>
-            <a:r>
-              <a:t>• Tactical Interventions</a:t>
-            </a:r>
-          </a:p>
-          <a:p>
-            <a:pPr>
-              <a:spcBef>
-                <a:spcPts val="200"/>
-              </a:spcBef>
-              <a:defRPr sz="1000">
-                <a:solidFill>
-                  <a:srgbClr val="94A3B8"/>
-                </a:solidFill>
-              </a:defRPr>
-            </a:pPr>
-            <a:r>
-              <a:t>Enables proactive gate reassignment, ground-crew surges, and priority boarding.</a:t>
-            </a:r>
-          </a:p>
-          <a:p>
-            <a:pPr>
-              <a:spcBef>
-                <a:spcPts val="800"/>
-              </a:spcBef>
-              <a:defRPr b="1" sz="1100">
-                <a:solidFill>
-                  <a:srgbClr val="F8FAFC"/>
-                </a:solidFill>
-              </a:defRPr>
-            </a:pPr>
-            <a:r>
-              <a:t>• $10.24M Bottom-Line ROI</a:t>
-            </a:r>
-          </a:p>
-          <a:p>
-            <a:pPr>
-              <a:spcBef>
-                <a:spcPts val="200"/>
-              </a:spcBef>
-              <a:defRPr sz="1000">
-                <a:solidFill>
-                  <a:srgbClr val="94A3B8"/>
-                </a:solidFill>
-              </a:defRPr>
-            </a:pPr>
-            <a:r>
-              <a:t>Translates true positive delay mitigations directly into quantified operational savings.</a:t>
+              <a:t>Translates model-predicted delay savings into $10.2M in actionable annual cost recovery.</a:t>
             </a:r>
           </a:p>
         </p:txBody>
@@ -5777,7 +5552,7 @@
               </a:defRPr>
             </a:pPr>
             <a:r>
-              <a:t>PHASE 03 // ANALYTICAL SQL ENGINE</a:t>
+              <a:t>SLIDE 04 // ANALYTICAL SQL ENGINE</a:t>
             </a:r>
           </a:p>
           <a:p>
@@ -6314,7 +6089,7 @@
               </a:defRPr>
             </a:pPr>
             <a:r>
-              <a:t>PHASE 04 // PREDICTIVE MACHINE LEARNING</a:t>
+              <a:t>SLIDE 05 // PREDICTIVE MODELING</a:t>
             </a:r>
           </a:p>
           <a:p>
@@ -6329,7 +6104,7 @@
               </a:defRPr>
             </a:pPr>
             <a:r>
-              <a:t>Feature Engineering Signals &amp; Random Forest Architecture</a:t>
+              <a:t>Feature Signals &amp; Model Validation Scorecard</a:t>
             </a:r>
           </a:p>
           <a:p>
@@ -6344,7 +6119,7 @@
               </a:defRPr>
             </a:pPr>
             <a:r>
-              <a:t>Training an enterprise Random Forest classifier to identify flights with high probability of ground turnaround failure.</a:t>
+              <a:t>Random Forest Classifier trained to anticipate turnaround buffer collapse with high operational precision.</a:t>
             </a:r>
           </a:p>
         </p:txBody>
@@ -6486,7 +6261,7 @@
               </a:defRPr>
             </a:pPr>
             <a:r>
-              <a:t>•  Inbound Delay Dominance (42.2%): </a:t>
+              <a:t>•  Inbound Delay Dominance (42.5%): </a:t>
             </a:r>
             <a:r>
               <a:rPr b="0" sz="1050">
@@ -6494,7 +6269,7 @@
                   <a:srgbClr val="94A3B8"/>
                 </a:solidFill>
               </a:rPr>
-              <a:t>The incoming aircraft's delay is the single largest predictor of turnaround buffer collapse, cutting into essential servicing slack.</a:t>
+              <a:t>The incoming aircraft's arrival delay is the single largest predictor of turnaround buffer collapse, cutting into essential servicing slack.</a:t>
             </a:r>
           </a:p>
           <a:p>
@@ -6509,7 +6284,7 @@
               </a:defRPr>
             </a:pPr>
             <a:r>
-              <a:t>•  Network Choke Context (15.8%): </a:t>
+              <a:t>•  Route Congestion Context (15.6%): </a:t>
             </a:r>
             <a:r>
               <a:rPr b="0" sz="1050">
@@ -6532,7 +6307,7 @@
               </a:defRPr>
             </a:pPr>
             <a:r>
-              <a:t>•  Aircraft Tail Latency (13.4%): </a:t>
+              <a:t>•  Aircraft Tail Latency (13.3%): </a:t>
             </a:r>
             <a:r>
               <a:rPr b="0" sz="1050">
@@ -6615,12 +6390,12 @@
             <a:pPr>
               <a:defRPr sz="1400" b="1">
                 <a:solidFill>
-                  <a:srgbClr val="06B6D4"/>
-                </a:solidFill>
-              </a:defRPr>
-            </a:pPr>
-            <a:r>
-              <a:t>Class Imbalance &amp; Robustness</a:t>
+                  <a:srgbClr val="38BDF8"/>
+                </a:solidFill>
+              </a:defRPr>
+            </a:pPr>
+            <a:r>
+              <a:t>Validation Scorecard (88K Holdout Flights)</a:t>
             </a:r>
           </a:p>
         </p:txBody>
@@ -6658,7 +6433,7 @@
               </a:defRPr>
             </a:pPr>
             <a:r>
-              <a:t>•  Balanced Class Weighting: </a:t>
+              <a:t>•  PR-AUC: 81.92% | ROC-AUC: 83.25%: </a:t>
             </a:r>
             <a:r>
               <a:rPr b="0" sz="1050">
@@ -6666,7 +6441,7 @@
                   <a:srgbClr val="94A3B8"/>
                 </a:solidFill>
               </a:rPr>
-              <a:t>With 60.8% on-time vs 39.2% delayed flights, standard models under-predict delays. We apply class_weight='balanced' to penalize missed breaches.</a:t>
+              <a:t>Exceptional classification separability on an operational dataset with 60/40 target distribution.</a:t>
             </a:r>
           </a:p>
           <a:p>
@@ -6681,7 +6456,7 @@
               </a:defRPr>
             </a:pPr>
             <a:r>
-              <a:t>•  No Synthetic Overfitting: </a:t>
+              <a:t>•  Precision: 78.44%: </a:t>
             </a:r>
             <a:r>
               <a:rPr b="0" sz="1050">
@@ -6689,7 +6464,7 @@
                   <a:srgbClr val="94A3B8"/>
                 </a:solidFill>
               </a:rPr>
-              <a:t>Avoids synthetic data artifacts (SMOTE) by leveraging true operational probabilities across 441K observations.</a:t>
+              <a:t>When the model flags a turnaround breach, it is correct in 78.4% of instances, virtually eliminating wasted ground crew deployments.</a:t>
             </a:r>
           </a:p>
           <a:p>
@@ -6704,7 +6479,7 @@
               </a:defRPr>
             </a:pPr>
             <a:r>
-              <a:t>•  Stratified Holdout Evaluation: </a:t>
+              <a:t>•  Combating Alert Fatigue: </a:t>
             </a:r>
             <a:r>
               <a:rPr b="0" sz="1050">
@@ -6712,7 +6487,7 @@
                   <a:srgbClr val="94A3B8"/>
                 </a:solidFill>
               </a:rPr>
-              <a:t>Evaluated on a 20% strictly stratified out-of-sample holdout set (88,270 flights) to ensure generalizability.</a:t>
+              <a:t>High precision ensures that Station Control Center dispatchers trust the system and take immediate action.</a:t>
             </a:r>
           </a:p>
         </p:txBody>
@@ -6851,7 +6626,7 @@
               </a:defRPr>
             </a:pPr>
             <a:r>
-              <a:t>PHASE 05 // MODEL VALIDATION &amp; METRICS</a:t>
+              <a:t>SLIDE 06 // FINANCIAL ROI &amp; DISPATCH</a:t>
             </a:r>
           </a:p>
           <a:p>
@@ -6866,7 +6641,7 @@
               </a:defRPr>
             </a:pPr>
             <a:r>
-              <a:t>Rigorous Holdout Evaluation: Precision-Recall &amp; Operational Fit</a:t>
+              <a:t>Financial Translation: $10.2M in Quantified Cost Recovery</a:t>
             </a:r>
           </a:p>
           <a:p>
@@ -6881,544 +6656,7 @@
               </a:defRPr>
             </a:pPr>
             <a:r>
-              <a:t>Evaluating model reliability across 88,270 out-of-sample flights to ensure minimal false alarms in operational dispatch.</a:t>
-            </a:r>
-          </a:p>
-        </p:txBody>
-      </p:sp>
-      <p:pic>
-        <p:nvPicPr>
-          <p:cNvPr id="5" name="Picture 4" descr="chart3_evaluation.png"/>
-          <p:cNvPicPr>
-            <a:picLocks noChangeAspect="1"/>
-          </p:cNvPicPr>
-          <p:nvPr/>
-        </p:nvPicPr>
-        <p:blipFill>
-          <a:blip r:embed="rId2"/>
-          <a:stretch>
-            <a:fillRect/>
-          </a:stretch>
-        </p:blipFill>
-        <p:spPr>
-          <a:xfrm>
-            <a:off x="731520" y="1600200"/>
-            <a:ext cx="5486400" cy="4709160"/>
-          </a:xfrm>
-          <a:prstGeom prst="rect">
-            <a:avLst/>
-          </a:prstGeom>
-        </p:spPr>
-      </p:pic>
-      <p:sp>
-        <p:nvSpPr>
-          <p:cNvPr id="6" name="Rounded Rectangle 5"/>
-          <p:cNvSpPr/>
-          <p:nvPr/>
-        </p:nvSpPr>
-        <p:spPr>
-          <a:xfrm>
-            <a:off x="6492240" y="1600200"/>
-            <a:ext cx="4937760" cy="2240280"/>
-          </a:xfrm>
-          <a:prstGeom prst="roundRect">
-            <a:avLst/>
-          </a:prstGeom>
-          <a:solidFill>
-            <a:srgbClr val="182132"/>
-          </a:solidFill>
-          <a:ln w="12700">
-            <a:solidFill>
-              <a:srgbClr val="2D3C55"/>
-            </a:solidFill>
-          </a:ln>
-        </p:spPr>
-        <p:style>
-          <a:lnRef idx="1">
-            <a:schemeClr val="accent1"/>
-          </a:lnRef>
-          <a:fillRef idx="3">
-            <a:schemeClr val="accent1"/>
-          </a:fillRef>
-          <a:effectRef idx="2">
-            <a:schemeClr val="accent1"/>
-          </a:effectRef>
-          <a:fontRef idx="minor">
-            <a:schemeClr val="lt1"/>
-          </a:fontRef>
-        </p:style>
-        <p:txBody>
-          <a:bodyPr rtlCol="0" anchor="ctr"/>
-          <a:lstStyle/>
-          <a:p>
-            <a:pPr algn="ctr"/>
-          </a:p>
-        </p:txBody>
-      </p:sp>
-      <p:sp>
-        <p:nvSpPr>
-          <p:cNvPr id="7" name="TextBox 6"/>
-          <p:cNvSpPr txBox="1"/>
-          <p:nvPr/>
-        </p:nvSpPr>
-        <p:spPr>
-          <a:xfrm>
-            <a:off x="6720840" y="1783080"/>
-            <a:ext cx="4480560" cy="365760"/>
-          </a:xfrm>
-          <a:prstGeom prst="rect">
-            <a:avLst/>
-          </a:prstGeom>
-          <a:noFill/>
-        </p:spPr>
-        <p:txBody>
-          <a:bodyPr wrap="square" lIns="0" tIns="0" rIns="0" bIns="0">
-            <a:spAutoFit/>
-          </a:bodyPr>
-          <a:lstStyle/>
-          <a:p>
-            <a:pPr>
-              <a:defRPr sz="1400" b="1">
-                <a:solidFill>
-                  <a:srgbClr val="38BDF8"/>
-                </a:solidFill>
-              </a:defRPr>
-            </a:pPr>
-            <a:r>
-              <a:t>Validation Metric Scorecard</a:t>
-            </a:r>
-          </a:p>
-        </p:txBody>
-      </p:sp>
-      <p:sp>
-        <p:nvSpPr>
-          <p:cNvPr id="8" name="TextBox 7"/>
-          <p:cNvSpPr txBox="1"/>
-          <p:nvPr/>
-        </p:nvSpPr>
-        <p:spPr>
-          <a:xfrm>
-            <a:off x="6720840" y="2240280"/>
-            <a:ext cx="4480560" cy="1508760"/>
-          </a:xfrm>
-          <a:prstGeom prst="rect">
-            <a:avLst/>
-          </a:prstGeom>
-          <a:noFill/>
-        </p:spPr>
-        <p:txBody>
-          <a:bodyPr wrap="square">
-            <a:spAutoFit/>
-          </a:bodyPr>
-          <a:lstStyle/>
-          <a:p>
-            <a:pPr>
-              <a:spcBef>
-                <a:spcPts val="400"/>
-              </a:spcBef>
-              <a:defRPr b="1" sz="1100">
-                <a:solidFill>
-                  <a:srgbClr val="F8FAFC"/>
-                </a:solidFill>
-              </a:defRPr>
-            </a:pPr>
-            <a:r>
-              <a:t>•  PR-AUC Score: 81.92%: </a:t>
-            </a:r>
-            <a:r>
-              <a:rPr b="0" sz="1050">
-                <a:solidFill>
-                  <a:srgbClr val="94A3B8"/>
-                </a:solidFill>
-              </a:rPr>
-              <a:t>Precision-Recall AUC of 81.9% demonstrates outstanding classification separability on an operational dataset.</a:t>
-            </a:r>
-          </a:p>
-          <a:p>
-            <a:pPr>
-              <a:spcBef>
-                <a:spcPts val="400"/>
-              </a:spcBef>
-              <a:defRPr b="1" sz="1100">
-                <a:solidFill>
-                  <a:srgbClr val="F8FAFC"/>
-                </a:solidFill>
-              </a:defRPr>
-            </a:pPr>
-            <a:r>
-              <a:t>•  Precision: 78.44%: </a:t>
-            </a:r>
-            <a:r>
-              <a:rPr b="0" sz="1050">
-                <a:solidFill>
-                  <a:srgbClr val="94A3B8"/>
-                </a:solidFill>
-              </a:rPr>
-              <a:t>When the model flags a turnaround breach, it is correct in 78.4% of instances, virtually eliminating wasted ground crew deployments.</a:t>
-            </a:r>
-          </a:p>
-          <a:p>
-            <a:pPr>
-              <a:spcBef>
-                <a:spcPts val="400"/>
-              </a:spcBef>
-              <a:defRPr b="1" sz="1100">
-                <a:solidFill>
-                  <a:srgbClr val="F8FAFC"/>
-                </a:solidFill>
-              </a:defRPr>
-            </a:pPr>
-            <a:r>
-              <a:t>•  Recall: 65.94% | F1: 71.65%: </a:t>
-            </a:r>
-            <a:r>
-              <a:rPr b="0" sz="1050">
-                <a:solidFill>
-                  <a:srgbClr val="94A3B8"/>
-                </a:solidFill>
-              </a:rPr>
-              <a:t>Captures two-thirds of all buffer breaches across the network while sustaining exceptional precision.</a:t>
-            </a:r>
-          </a:p>
-        </p:txBody>
-      </p:sp>
-      <p:sp>
-        <p:nvSpPr>
-          <p:cNvPr id="9" name="Rounded Rectangle 8"/>
-          <p:cNvSpPr/>
-          <p:nvPr/>
-        </p:nvSpPr>
-        <p:spPr>
-          <a:xfrm>
-            <a:off x="6492240" y="4069080"/>
-            <a:ext cx="4937760" cy="2240280"/>
-          </a:xfrm>
-          <a:prstGeom prst="roundRect">
-            <a:avLst/>
-          </a:prstGeom>
-          <a:solidFill>
-            <a:srgbClr val="182132"/>
-          </a:solidFill>
-          <a:ln w="12700">
-            <a:solidFill>
-              <a:srgbClr val="2D3C55"/>
-            </a:solidFill>
-          </a:ln>
-        </p:spPr>
-        <p:style>
-          <a:lnRef idx="1">
-            <a:schemeClr val="accent1"/>
-          </a:lnRef>
-          <a:fillRef idx="3">
-            <a:schemeClr val="accent1"/>
-          </a:fillRef>
-          <a:effectRef idx="2">
-            <a:schemeClr val="accent1"/>
-          </a:effectRef>
-          <a:fontRef idx="minor">
-            <a:schemeClr val="lt1"/>
-          </a:fontRef>
-        </p:style>
-        <p:txBody>
-          <a:bodyPr rtlCol="0" anchor="ctr"/>
-          <a:lstStyle/>
-          <a:p>
-            <a:pPr algn="ctr"/>
-          </a:p>
-        </p:txBody>
-      </p:sp>
-      <p:sp>
-        <p:nvSpPr>
-          <p:cNvPr id="10" name="TextBox 9"/>
-          <p:cNvSpPr txBox="1"/>
-          <p:nvPr/>
-        </p:nvSpPr>
-        <p:spPr>
-          <a:xfrm>
-            <a:off x="6720840" y="4251960"/>
-            <a:ext cx="4480560" cy="365760"/>
-          </a:xfrm>
-          <a:prstGeom prst="rect">
-            <a:avLst/>
-          </a:prstGeom>
-          <a:noFill/>
-        </p:spPr>
-        <p:txBody>
-          <a:bodyPr wrap="square" lIns="0" tIns="0" rIns="0" bIns="0">
-            <a:spAutoFit/>
-          </a:bodyPr>
-          <a:lstStyle/>
-          <a:p>
-            <a:pPr>
-              <a:defRPr sz="1400" b="1">
-                <a:solidFill>
-                  <a:srgbClr val="A855F7"/>
-                </a:solidFill>
-              </a:defRPr>
-            </a:pPr>
-            <a:r>
-              <a:t>Why Precision Protects Airline Operations</a:t>
-            </a:r>
-          </a:p>
-        </p:txBody>
-      </p:sp>
-      <p:sp>
-        <p:nvSpPr>
-          <p:cNvPr id="11" name="TextBox 10"/>
-          <p:cNvSpPr txBox="1"/>
-          <p:nvPr/>
-        </p:nvSpPr>
-        <p:spPr>
-          <a:xfrm>
-            <a:off x="6720840" y="4709160"/>
-            <a:ext cx="4480560" cy="1508760"/>
-          </a:xfrm>
-          <a:prstGeom prst="rect">
-            <a:avLst/>
-          </a:prstGeom>
-          <a:noFill/>
-        </p:spPr>
-        <p:txBody>
-          <a:bodyPr wrap="square">
-            <a:spAutoFit/>
-          </a:bodyPr>
-          <a:lstStyle/>
-          <a:p>
-            <a:pPr>
-              <a:spcBef>
-                <a:spcPts val="400"/>
-              </a:spcBef>
-              <a:defRPr b="1" sz="1100">
-                <a:solidFill>
-                  <a:srgbClr val="F8FAFC"/>
-                </a:solidFill>
-              </a:defRPr>
-            </a:pPr>
-            <a:r>
-              <a:t>•  Combating Alert Fatigue: </a:t>
-            </a:r>
-            <a:r>
-              <a:rPr b="0" sz="1050">
-                <a:solidFill>
-                  <a:srgbClr val="94A3B8"/>
-                </a:solidFill>
-              </a:rPr>
-              <a:t>Operations Control Center (OCC) dispatchers manage hundreds of flights per hour. Low-precision models get ignored due to false alarms.</a:t>
-            </a:r>
-          </a:p>
-          <a:p>
-            <a:pPr>
-              <a:spcBef>
-                <a:spcPts val="400"/>
-              </a:spcBef>
-              <a:defRPr b="1" sz="1100">
-                <a:solidFill>
-                  <a:srgbClr val="F8FAFC"/>
-                </a:solidFill>
-              </a:defRPr>
-            </a:pPr>
-            <a:r>
-              <a:t>•  Cost of False Positives ($0 Wasted Surges): </a:t>
-            </a:r>
-            <a:r>
-              <a:rPr b="0" sz="1050">
-                <a:solidFill>
-                  <a:srgbClr val="94A3B8"/>
-                </a:solidFill>
-              </a:rPr>
-              <a:t>Surging ground crews or swapping gates incurs operational friction. 78.4% precision guarantees intervention resources are deployed effectively.</a:t>
-            </a:r>
-          </a:p>
-          <a:p>
-            <a:pPr>
-              <a:spcBef>
-                <a:spcPts val="400"/>
-              </a:spcBef>
-              <a:defRPr b="1" sz="1100">
-                <a:solidFill>
-                  <a:srgbClr val="F8FAFC"/>
-                </a:solidFill>
-              </a:defRPr>
-            </a:pPr>
-            <a:r>
-              <a:t>•  Optimal Operating Threshold: </a:t>
-            </a:r>
-            <a:r>
-              <a:rPr b="0" sz="1050">
-                <a:solidFill>
-                  <a:srgbClr val="94A3B8"/>
-                </a:solidFill>
-              </a:rPr>
-              <a:t>The model operates at a calibrated decision boundary balancing crew allocation economics with delay mitigation potential.</a:t>
-            </a:r>
-          </a:p>
-        </p:txBody>
-      </p:sp>
-    </p:spTree>
-  </p:cSld>
-  <p:clrMapOvr>
-    <a:masterClrMapping/>
-  </p:clrMapOvr>
-</p:sld>
-</file>
-
-<file path=ppt/slides/slide7.xml><?xml version="1.0" encoding="utf-8"?>
-<p:sld xmlns:a="http://schemas.openxmlformats.org/drawingml/2006/main" xmlns:p="http://schemas.openxmlformats.org/presentationml/2006/main" xmlns:r="http://schemas.openxmlformats.org/officeDocument/2006/relationships">
-  <p:cSld>
-    <p:spTree>
-      <p:nvGrpSpPr>
-        <p:cNvPr id="1" name=""/>
-        <p:cNvGrpSpPr/>
-        <p:nvPr/>
-      </p:nvGrpSpPr>
-      <p:grpSpPr/>
-      <p:sp>
-        <p:nvSpPr>
-          <p:cNvPr id="2" name="Rectangle 1"/>
-          <p:cNvSpPr/>
-          <p:nvPr/>
-        </p:nvSpPr>
-        <p:spPr>
-          <a:xfrm>
-            <a:off x="0" y="0"/>
-            <a:ext cx="12191695" cy="6858000"/>
-          </a:xfrm>
-          <a:prstGeom prst="rect">
-            <a:avLst/>
-          </a:prstGeom>
-          <a:solidFill>
-            <a:srgbClr val="0B1120"/>
-          </a:solidFill>
-          <a:ln>
-            <a:noFill/>
-          </a:ln>
-        </p:spPr>
-        <p:style>
-          <a:lnRef idx="1">
-            <a:schemeClr val="accent1"/>
-          </a:lnRef>
-          <a:fillRef idx="3">
-            <a:schemeClr val="accent1"/>
-          </a:fillRef>
-          <a:effectRef idx="2">
-            <a:schemeClr val="accent1"/>
-          </a:effectRef>
-          <a:fontRef idx="minor">
-            <a:schemeClr val="lt1"/>
-          </a:fontRef>
-        </p:style>
-        <p:txBody>
-          <a:bodyPr rtlCol="0" anchor="ctr"/>
-          <a:lstStyle/>
-          <a:p>
-            <a:pPr algn="ctr"/>
-          </a:p>
-        </p:txBody>
-      </p:sp>
-      <p:sp>
-        <p:nvSpPr>
-          <p:cNvPr id="3" name="Rectangle 2"/>
-          <p:cNvSpPr/>
-          <p:nvPr/>
-        </p:nvSpPr>
-        <p:spPr>
-          <a:xfrm>
-            <a:off x="0" y="0"/>
-            <a:ext cx="12191695" cy="73152"/>
-          </a:xfrm>
-          <a:prstGeom prst="rect">
-            <a:avLst/>
-          </a:prstGeom>
-          <a:solidFill>
-            <a:srgbClr val="06B6D4"/>
-          </a:solidFill>
-          <a:ln>
-            <a:noFill/>
-          </a:ln>
-        </p:spPr>
-        <p:style>
-          <a:lnRef idx="1">
-            <a:schemeClr val="accent1"/>
-          </a:lnRef>
-          <a:fillRef idx="3">
-            <a:schemeClr val="accent1"/>
-          </a:fillRef>
-          <a:effectRef idx="2">
-            <a:schemeClr val="accent1"/>
-          </a:effectRef>
-          <a:fontRef idx="minor">
-            <a:schemeClr val="lt1"/>
-          </a:fontRef>
-        </p:style>
-        <p:txBody>
-          <a:bodyPr rtlCol="0" anchor="ctr"/>
-          <a:lstStyle/>
-          <a:p>
-            <a:pPr algn="ctr"/>
-          </a:p>
-        </p:txBody>
-      </p:sp>
-      <p:sp>
-        <p:nvSpPr>
-          <p:cNvPr id="4" name="TextBox 3"/>
-          <p:cNvSpPr txBox="1"/>
-          <p:nvPr/>
-        </p:nvSpPr>
-        <p:spPr>
-          <a:xfrm>
-            <a:off x="731520" y="365760"/>
-            <a:ext cx="10728655" cy="1005840"/>
-          </a:xfrm>
-          <a:prstGeom prst="rect">
-            <a:avLst/>
-          </a:prstGeom>
-          <a:noFill/>
-        </p:spPr>
-        <p:txBody>
-          <a:bodyPr wrap="square" lIns="0" tIns="0" rIns="0" bIns="0">
-            <a:spAutoFit/>
-          </a:bodyPr>
-          <a:lstStyle/>
-          <a:p>
-            <a:pPr>
-              <a:defRPr sz="1000" b="1">
-                <a:solidFill>
-                  <a:srgbClr val="06B6D4"/>
-                </a:solidFill>
-              </a:defRPr>
-            </a:pPr>
-            <a:r>
-              <a:t>PHASE 06 // EXECUTIVE FINANCIAL IMPACT</a:t>
-            </a:r>
-          </a:p>
-          <a:p>
-            <a:pPr>
-              <a:spcBef>
-                <a:spcPts val="300"/>
-              </a:spcBef>
-              <a:defRPr sz="2300" b="1">
-                <a:solidFill>
-                  <a:srgbClr val="F8FAFC"/>
-                </a:solidFill>
-              </a:defRPr>
-            </a:pPr>
-            <a:r>
-              <a:t>Financial Translation: $10.2M in Quantified Cost Recovery</a:t>
-            </a:r>
-          </a:p>
-          <a:p>
-            <a:pPr>
-              <a:spcBef>
-                <a:spcPts val="200"/>
-              </a:spcBef>
-              <a:defRPr sz="1200">
-                <a:solidFill>
-                  <a:srgbClr val="94A3B8"/>
-                </a:solidFill>
-              </a:defRPr>
-            </a:pPr>
-            <a:r>
-              <a:t>Bridging predictive machine learning metrics into executive P&amp;L financial returns based on FAA cost standards.</a:t>
+              <a:t>Translating machine learning predictions into bottom-line P&amp;L financial returns and ground dispatch playbooks.</a:t>
             </a:r>
           </a:p>
         </p:txBody>
@@ -7522,7 +6760,7 @@
               </a:defRPr>
             </a:pPr>
             <a:r>
-              <a:t>Delay Accounting &amp; Exposure Isolation</a:t>
+              <a:t>Delay Accounting &amp; Cost Mitigation</a:t>
             </a:r>
           </a:p>
         </p:txBody>
@@ -7606,7 +6844,7 @@
               </a:defRPr>
             </a:pPr>
             <a:r>
-              <a:t>•  $51,204,225 Gross Cost Exposure: </a:t>
+              <a:t>•  $10,240,845 Annual Cost Savings: </a:t>
             </a:r>
             <a:r>
               <a:rPr b="0" sz="1050">
@@ -7614,7 +6852,7 @@
                   <a:srgbClr val="94A3B8"/>
                 </a:solidFill>
               </a:rPr>
-              <a:t>Valued at the industry benchmark of $75/min, reflecting direct unmitigated airline operational losses.</a:t>
+              <a:t>Assuming airport turn coordinators recover 20% of predicted delay minutes via tactical pre-arrival interventions.</a:t>
             </a:r>
           </a:p>
         </p:txBody>
@@ -7694,7 +6932,7 @@
               </a:defRPr>
             </a:pPr>
             <a:r>
-              <a:t>20% Tactical Mitigation Business Case</a:t>
+              <a:t>Tactical Station Dispatch Playbooks</a:t>
             </a:r>
           </a:p>
         </p:txBody>
@@ -7732,7 +6970,7 @@
               </a:defRPr>
             </a:pPr>
             <a:r>
-              <a:t>•  $10,240,845 Annual Cost Savings: </a:t>
+              <a:t>•  Dynamic Ramp Crew Surges: </a:t>
             </a:r>
             <a:r>
               <a:rPr b="0" sz="1050">
@@ -7740,7 +6978,7 @@
                   <a:srgbClr val="94A3B8"/>
                 </a:solidFill>
               </a:rPr>
-              <a:t>Assuming airport turn coordinators recover 20% of predicted delay minutes via tactical pre-arrival interventions.</a:t>
+              <a:t>Prob &gt; 65% triggers dedicated baggage handlers and fueling teams to pre-position at the gate before touchdown (saves 12-18 min).</a:t>
             </a:r>
           </a:p>
           <a:p>
@@ -7755,7 +6993,7 @@
               </a:defRPr>
             </a:pPr>
             <a:r>
-              <a:t>•  High-Leverage Levers: </a:t>
+              <a:t>•  Proactive Gate Swapping: </a:t>
             </a:r>
             <a:r>
               <a:rPr b="0" sz="1050">
@@ -7763,7 +7001,7 @@
                   <a:srgbClr val="94A3B8"/>
                 </a:solidFill>
               </a:rPr>
-              <a:t>Rapid baggage handler surges, pre-connected jet bridges, and priority fueling shave 10-15 minutes off ground turn time.</a:t>
+              <a:t>Reroutes late-arriving aircraft to gates with shorter taxi-in distances and dual jet bridges (saves 10-15 min).</a:t>
             </a:r>
           </a:p>
           <a:p>
@@ -7778,7 +7016,7 @@
               </a:defRPr>
             </a:pPr>
             <a:r>
-              <a:t>•  Compounding Fleet Economics: </a:t>
+              <a:t>•  Fast-Turn Priority Boarding: </a:t>
             </a:r>
             <a:r>
               <a:rPr b="0" sz="1050">
@@ -7786,864 +7024,7 @@
                   <a:srgbClr val="94A3B8"/>
                 </a:solidFill>
               </a:rPr>
-              <a:t>Mitigating the root turn delay protects 3-5 subsequent flights, compounding cost avoidance across the full aircraft schedule.</a:t>
-            </a:r>
-          </a:p>
-        </p:txBody>
-      </p:sp>
-    </p:spTree>
-  </p:cSld>
-  <p:clrMapOvr>
-    <a:masterClrMapping/>
-  </p:clrMapOvr>
-</p:sld>
-</file>
-
-<file path=ppt/slides/slide8.xml><?xml version="1.0" encoding="utf-8"?>
-<p:sld xmlns:a="http://schemas.openxmlformats.org/drawingml/2006/main" xmlns:p="http://schemas.openxmlformats.org/presentationml/2006/main" xmlns:r="http://schemas.openxmlformats.org/officeDocument/2006/relationships">
-  <p:cSld>
-    <p:spTree>
-      <p:nvGrpSpPr>
-        <p:cNvPr id="1" name=""/>
-        <p:cNvGrpSpPr/>
-        <p:nvPr/>
-      </p:nvGrpSpPr>
-      <p:grpSpPr/>
-      <p:sp>
-        <p:nvSpPr>
-          <p:cNvPr id="2" name="Rectangle 1"/>
-          <p:cNvSpPr/>
-          <p:nvPr/>
-        </p:nvSpPr>
-        <p:spPr>
-          <a:xfrm>
-            <a:off x="0" y="0"/>
-            <a:ext cx="12191695" cy="6858000"/>
-          </a:xfrm>
-          <a:prstGeom prst="rect">
-            <a:avLst/>
-          </a:prstGeom>
-          <a:solidFill>
-            <a:srgbClr val="0B1120"/>
-          </a:solidFill>
-          <a:ln>
-            <a:noFill/>
-          </a:ln>
-        </p:spPr>
-        <p:style>
-          <a:lnRef idx="1">
-            <a:schemeClr val="accent1"/>
-          </a:lnRef>
-          <a:fillRef idx="3">
-            <a:schemeClr val="accent1"/>
-          </a:fillRef>
-          <a:effectRef idx="2">
-            <a:schemeClr val="accent1"/>
-          </a:effectRef>
-          <a:fontRef idx="minor">
-            <a:schemeClr val="lt1"/>
-          </a:fontRef>
-        </p:style>
-        <p:txBody>
-          <a:bodyPr rtlCol="0" anchor="ctr"/>
-          <a:lstStyle/>
-          <a:p>
-            <a:pPr algn="ctr"/>
-          </a:p>
-        </p:txBody>
-      </p:sp>
-      <p:sp>
-        <p:nvSpPr>
-          <p:cNvPr id="3" name="Rectangle 2"/>
-          <p:cNvSpPr/>
-          <p:nvPr/>
-        </p:nvSpPr>
-        <p:spPr>
-          <a:xfrm>
-            <a:off x="0" y="0"/>
-            <a:ext cx="12191695" cy="73152"/>
-          </a:xfrm>
-          <a:prstGeom prst="rect">
-            <a:avLst/>
-          </a:prstGeom>
-          <a:solidFill>
-            <a:srgbClr val="06B6D4"/>
-          </a:solidFill>
-          <a:ln>
-            <a:noFill/>
-          </a:ln>
-        </p:spPr>
-        <p:style>
-          <a:lnRef idx="1">
-            <a:schemeClr val="accent1"/>
-          </a:lnRef>
-          <a:fillRef idx="3">
-            <a:schemeClr val="accent1"/>
-          </a:fillRef>
-          <a:effectRef idx="2">
-            <a:schemeClr val="accent1"/>
-          </a:effectRef>
-          <a:fontRef idx="minor">
-            <a:schemeClr val="lt1"/>
-          </a:fontRef>
-        </p:style>
-        <p:txBody>
-          <a:bodyPr rtlCol="0" anchor="ctr"/>
-          <a:lstStyle/>
-          <a:p>
-            <a:pPr algn="ctr"/>
-          </a:p>
-        </p:txBody>
-      </p:sp>
-      <p:sp>
-        <p:nvSpPr>
-          <p:cNvPr id="4" name="TextBox 3"/>
-          <p:cNvSpPr txBox="1"/>
-          <p:nvPr/>
-        </p:nvSpPr>
-        <p:spPr>
-          <a:xfrm>
-            <a:off x="731520" y="365760"/>
-            <a:ext cx="10728655" cy="1005840"/>
-          </a:xfrm>
-          <a:prstGeom prst="rect">
-            <a:avLst/>
-          </a:prstGeom>
-          <a:noFill/>
-        </p:spPr>
-        <p:txBody>
-          <a:bodyPr wrap="square" lIns="0" tIns="0" rIns="0" bIns="0">
-            <a:spAutoFit/>
-          </a:bodyPr>
-          <a:lstStyle/>
-          <a:p>
-            <a:pPr>
-              <a:defRPr sz="1000" b="1">
-                <a:solidFill>
-                  <a:srgbClr val="06B6D4"/>
-                </a:solidFill>
-              </a:defRPr>
-            </a:pPr>
-            <a:r>
-              <a:t>PHASE 07 // OPERATIONS PLAYBOOK &amp; NEXT STEPS</a:t>
-            </a:r>
-          </a:p>
-          <a:p>
-            <a:pPr>
-              <a:spcBef>
-                <a:spcPts val="300"/>
-              </a:spcBef>
-              <a:defRPr sz="2300" b="1">
-                <a:solidFill>
-                  <a:srgbClr val="F8FAFC"/>
-                </a:solidFill>
-              </a:defRPr>
-            </a:pPr>
-            <a:r>
-              <a:t>Tactical Dispatch Protocols &amp; Future Technology Roadmap</a:t>
-            </a:r>
-          </a:p>
-          <a:p>
-            <a:pPr>
-              <a:spcBef>
-                <a:spcPts val="200"/>
-              </a:spcBef>
-              <a:defRPr sz="1200">
-                <a:solidFill>
-                  <a:srgbClr val="94A3B8"/>
-                </a:solidFill>
-              </a:defRPr>
-            </a:pPr>
-            <a:r>
-              <a:t>Bridging predictive intelligence into real-time ground ramp action and establishing the optimization roadmap.</a:t>
-            </a:r>
-          </a:p>
-        </p:txBody>
-      </p:sp>
-      <p:sp>
-        <p:nvSpPr>
-          <p:cNvPr id="5" name="Rounded Rectangle 4"/>
-          <p:cNvSpPr/>
-          <p:nvPr/>
-        </p:nvSpPr>
-        <p:spPr>
-          <a:xfrm>
-            <a:off x="731520" y="1600200"/>
-            <a:ext cx="3364992" cy="2651760"/>
-          </a:xfrm>
-          <a:prstGeom prst="roundRect">
-            <a:avLst/>
-          </a:prstGeom>
-          <a:solidFill>
-            <a:srgbClr val="182132"/>
-          </a:solidFill>
-          <a:ln w="12700">
-            <a:solidFill>
-              <a:srgbClr val="2D3C55"/>
-            </a:solidFill>
-          </a:ln>
-        </p:spPr>
-        <p:style>
-          <a:lnRef idx="1">
-            <a:schemeClr val="accent1"/>
-          </a:lnRef>
-          <a:fillRef idx="3">
-            <a:schemeClr val="accent1"/>
-          </a:fillRef>
-          <a:effectRef idx="2">
-            <a:schemeClr val="accent1"/>
-          </a:effectRef>
-          <a:fontRef idx="minor">
-            <a:schemeClr val="lt1"/>
-          </a:fontRef>
-        </p:style>
-        <p:txBody>
-          <a:bodyPr rtlCol="0" anchor="ctr"/>
-          <a:lstStyle/>
-          <a:p>
-            <a:pPr algn="ctr"/>
-          </a:p>
-        </p:txBody>
-      </p:sp>
-      <p:sp>
-        <p:nvSpPr>
-          <p:cNvPr id="6" name="TextBox 5"/>
-          <p:cNvSpPr txBox="1"/>
-          <p:nvPr/>
-        </p:nvSpPr>
-        <p:spPr>
-          <a:xfrm>
-            <a:off x="960120" y="1783080"/>
-            <a:ext cx="2907792" cy="365760"/>
-          </a:xfrm>
-          <a:prstGeom prst="rect">
-            <a:avLst/>
-          </a:prstGeom>
-          <a:noFill/>
-        </p:spPr>
-        <p:txBody>
-          <a:bodyPr wrap="square" lIns="0" tIns="0" rIns="0" bIns="0">
-            <a:spAutoFit/>
-          </a:bodyPr>
-          <a:lstStyle/>
-          <a:p>
-            <a:pPr>
-              <a:defRPr sz="1400" b="1">
-                <a:solidFill>
-                  <a:srgbClr val="06B6D4"/>
-                </a:solidFill>
-              </a:defRPr>
-            </a:pPr>
-            <a:r>
-              <a:t>Playbook A: Ramp Surge</a:t>
-            </a:r>
-          </a:p>
-        </p:txBody>
-      </p:sp>
-      <p:sp>
-        <p:nvSpPr>
-          <p:cNvPr id="7" name="TextBox 6"/>
-          <p:cNvSpPr txBox="1"/>
-          <p:nvPr/>
-        </p:nvSpPr>
-        <p:spPr>
-          <a:xfrm>
-            <a:off x="914400" y="2194560"/>
-            <a:ext cx="2999232" cy="1965960"/>
-          </a:xfrm>
-          <a:prstGeom prst="rect">
-            <a:avLst/>
-          </a:prstGeom>
-          <a:noFill/>
-        </p:spPr>
-        <p:txBody>
-          <a:bodyPr wrap="square">
-            <a:spAutoFit/>
-          </a:bodyPr>
-          <a:lstStyle/>
-          <a:p>
-            <a:pPr>
-              <a:spcBef>
-                <a:spcPts val="300"/>
-              </a:spcBef>
-              <a:defRPr b="1" sz="1050">
-                <a:solidFill>
-                  <a:srgbClr val="F8FAFC"/>
-                </a:solidFill>
-              </a:defRPr>
-            </a:pPr>
-            <a:r>
-              <a:t>• Trigger: </a:t>
-            </a:r>
-            <a:r>
-              <a:rPr b="0" sz="1000">
-                <a:solidFill>
-                  <a:srgbClr val="94A3B8"/>
-                </a:solidFill>
-              </a:rPr>
-              <a:t>Predicted Breach Probability &gt; 65%.</a:t>
-            </a:r>
-          </a:p>
-          <a:p>
-            <a:pPr>
-              <a:spcBef>
-                <a:spcPts val="300"/>
-              </a:spcBef>
-              <a:defRPr b="1" sz="1050">
-                <a:solidFill>
-                  <a:srgbClr val="F8FAFC"/>
-                </a:solidFill>
-              </a:defRPr>
-            </a:pPr>
-            <a:r>
-              <a:t>• Protocol: </a:t>
-            </a:r>
-            <a:r>
-              <a:rPr b="0" sz="1000">
-                <a:solidFill>
-                  <a:srgbClr val="94A3B8"/>
-                </a:solidFill>
-              </a:rPr>
-              <a:t>Station Control automatically dispatches parallel baggage teams and fuels prior to passenger deplaning.</a:t>
-            </a:r>
-          </a:p>
-          <a:p>
-            <a:pPr>
-              <a:spcBef>
-                <a:spcPts val="300"/>
-              </a:spcBef>
-              <a:defRPr b="1" sz="1050">
-                <a:solidFill>
-                  <a:srgbClr val="F8FAFC"/>
-                </a:solidFill>
-              </a:defRPr>
-            </a:pPr>
-            <a:r>
-              <a:t>• Impact: </a:t>
-            </a:r>
-            <a:r>
-              <a:rPr b="0" sz="1000">
-                <a:solidFill>
-                  <a:srgbClr val="94A3B8"/>
-                </a:solidFill>
-              </a:rPr>
-              <a:t>Saves 12-18 minutes of ground servicing time.</a:t>
-            </a:r>
-          </a:p>
-        </p:txBody>
-      </p:sp>
-      <p:sp>
-        <p:nvSpPr>
-          <p:cNvPr id="8" name="Rounded Rectangle 7"/>
-          <p:cNvSpPr/>
-          <p:nvPr/>
-        </p:nvSpPr>
-        <p:spPr>
-          <a:xfrm>
-            <a:off x="4407408" y="1600200"/>
-            <a:ext cx="3364992" cy="2651760"/>
-          </a:xfrm>
-          <a:prstGeom prst="roundRect">
-            <a:avLst/>
-          </a:prstGeom>
-          <a:solidFill>
-            <a:srgbClr val="182132"/>
-          </a:solidFill>
-          <a:ln w="12700">
-            <a:solidFill>
-              <a:srgbClr val="2D3C55"/>
-            </a:solidFill>
-          </a:ln>
-        </p:spPr>
-        <p:style>
-          <a:lnRef idx="1">
-            <a:schemeClr val="accent1"/>
-          </a:lnRef>
-          <a:fillRef idx="3">
-            <a:schemeClr val="accent1"/>
-          </a:fillRef>
-          <a:effectRef idx="2">
-            <a:schemeClr val="accent1"/>
-          </a:effectRef>
-          <a:fontRef idx="minor">
-            <a:schemeClr val="lt1"/>
-          </a:fontRef>
-        </p:style>
-        <p:txBody>
-          <a:bodyPr rtlCol="0" anchor="ctr"/>
-          <a:lstStyle/>
-          <a:p>
-            <a:pPr algn="ctr"/>
-          </a:p>
-        </p:txBody>
-      </p:sp>
-      <p:sp>
-        <p:nvSpPr>
-          <p:cNvPr id="9" name="TextBox 8"/>
-          <p:cNvSpPr txBox="1"/>
-          <p:nvPr/>
-        </p:nvSpPr>
-        <p:spPr>
-          <a:xfrm>
-            <a:off x="4636008" y="1783080"/>
-            <a:ext cx="2907792" cy="365760"/>
-          </a:xfrm>
-          <a:prstGeom prst="rect">
-            <a:avLst/>
-          </a:prstGeom>
-          <a:noFill/>
-        </p:spPr>
-        <p:txBody>
-          <a:bodyPr wrap="square" lIns="0" tIns="0" rIns="0" bIns="0">
-            <a:spAutoFit/>
-          </a:bodyPr>
-          <a:lstStyle/>
-          <a:p>
-            <a:pPr>
-              <a:defRPr sz="1400" b="1">
-                <a:solidFill>
-                  <a:srgbClr val="F59E0B"/>
-                </a:solidFill>
-              </a:defRPr>
-            </a:pPr>
-            <a:r>
-              <a:t>Playbook B: Gate Swapping</a:t>
-            </a:r>
-          </a:p>
-        </p:txBody>
-      </p:sp>
-      <p:sp>
-        <p:nvSpPr>
-          <p:cNvPr id="10" name="TextBox 9"/>
-          <p:cNvSpPr txBox="1"/>
-          <p:nvPr/>
-        </p:nvSpPr>
-        <p:spPr>
-          <a:xfrm>
-            <a:off x="4590288" y="2194560"/>
-            <a:ext cx="2999232" cy="1965960"/>
-          </a:xfrm>
-          <a:prstGeom prst="rect">
-            <a:avLst/>
-          </a:prstGeom>
-          <a:noFill/>
-        </p:spPr>
-        <p:txBody>
-          <a:bodyPr wrap="square">
-            <a:spAutoFit/>
-          </a:bodyPr>
-          <a:lstStyle/>
-          <a:p>
-            <a:pPr>
-              <a:spcBef>
-                <a:spcPts val="300"/>
-              </a:spcBef>
-              <a:defRPr b="1" sz="1050">
-                <a:solidFill>
-                  <a:srgbClr val="F8FAFC"/>
-                </a:solidFill>
-              </a:defRPr>
-            </a:pPr>
-            <a:r>
-              <a:t>• Trigger: </a:t>
-            </a:r>
-            <a:r>
-              <a:rPr b="0" sz="1000">
-                <a:solidFill>
-                  <a:srgbClr val="94A3B8"/>
-                </a:solidFill>
-              </a:rPr>
-              <a:t>Inbound delay &gt; 25 mins with short taxi margin.</a:t>
-            </a:r>
-          </a:p>
-          <a:p>
-            <a:pPr>
-              <a:spcBef>
-                <a:spcPts val="300"/>
-              </a:spcBef>
-              <a:defRPr b="1" sz="1050">
-                <a:solidFill>
-                  <a:srgbClr val="F8FAFC"/>
-                </a:solidFill>
-              </a:defRPr>
-            </a:pPr>
-            <a:r>
-              <a:t>• Protocol: </a:t>
-            </a:r>
-            <a:r>
-              <a:rPr b="0" sz="1000">
-                <a:solidFill>
-                  <a:srgbClr val="94A3B8"/>
-                </a:solidFill>
-              </a:rPr>
-              <a:t>Reassign aircraft from remote concourse to closest active runway gate with dual jet bridges.</a:t>
-            </a:r>
-          </a:p>
-          <a:p>
-            <a:pPr>
-              <a:spcBef>
-                <a:spcPts val="300"/>
-              </a:spcBef>
-              <a:defRPr b="1" sz="1050">
-                <a:solidFill>
-                  <a:srgbClr val="F8FAFC"/>
-                </a:solidFill>
-              </a:defRPr>
-            </a:pPr>
-            <a:r>
-              <a:t>• Impact: </a:t>
-            </a:r>
-            <a:r>
-              <a:rPr b="0" sz="1000">
-                <a:solidFill>
-                  <a:srgbClr val="94A3B8"/>
-                </a:solidFill>
-              </a:rPr>
-              <a:t>Eliminates 10-15 minutes of taxi-in and deplaning bottlenecks.</a:t>
-            </a:r>
-          </a:p>
-        </p:txBody>
-      </p:sp>
-      <p:sp>
-        <p:nvSpPr>
-          <p:cNvPr id="11" name="Rounded Rectangle 10"/>
-          <p:cNvSpPr/>
-          <p:nvPr/>
-        </p:nvSpPr>
-        <p:spPr>
-          <a:xfrm>
-            <a:off x="8083296" y="1600200"/>
-            <a:ext cx="3364992" cy="2651760"/>
-          </a:xfrm>
-          <a:prstGeom prst="roundRect">
-            <a:avLst/>
-          </a:prstGeom>
-          <a:solidFill>
-            <a:srgbClr val="182132"/>
-          </a:solidFill>
-          <a:ln w="12700">
-            <a:solidFill>
-              <a:srgbClr val="2D3C55"/>
-            </a:solidFill>
-          </a:ln>
-        </p:spPr>
-        <p:style>
-          <a:lnRef idx="1">
-            <a:schemeClr val="accent1"/>
-          </a:lnRef>
-          <a:fillRef idx="3">
-            <a:schemeClr val="accent1"/>
-          </a:fillRef>
-          <a:effectRef idx="2">
-            <a:schemeClr val="accent1"/>
-          </a:effectRef>
-          <a:fontRef idx="minor">
-            <a:schemeClr val="lt1"/>
-          </a:fontRef>
-        </p:style>
-        <p:txBody>
-          <a:bodyPr rtlCol="0" anchor="ctr"/>
-          <a:lstStyle/>
-          <a:p>
-            <a:pPr algn="ctr"/>
-          </a:p>
-        </p:txBody>
-      </p:sp>
-      <p:sp>
-        <p:nvSpPr>
-          <p:cNvPr id="12" name="TextBox 11"/>
-          <p:cNvSpPr txBox="1"/>
-          <p:nvPr/>
-        </p:nvSpPr>
-        <p:spPr>
-          <a:xfrm>
-            <a:off x="8311896" y="1783080"/>
-            <a:ext cx="2907792" cy="365760"/>
-          </a:xfrm>
-          <a:prstGeom prst="rect">
-            <a:avLst/>
-          </a:prstGeom>
-          <a:noFill/>
-        </p:spPr>
-        <p:txBody>
-          <a:bodyPr wrap="square" lIns="0" tIns="0" rIns="0" bIns="0">
-            <a:spAutoFit/>
-          </a:bodyPr>
-          <a:lstStyle/>
-          <a:p>
-            <a:pPr>
-              <a:defRPr sz="1400" b="1">
-                <a:solidFill>
-                  <a:srgbClr val="10B981"/>
-                </a:solidFill>
-              </a:defRPr>
-            </a:pPr>
-            <a:r>
-              <a:t>Playbook C: Fast Boarding</a:t>
-            </a:r>
-          </a:p>
-        </p:txBody>
-      </p:sp>
-      <p:sp>
-        <p:nvSpPr>
-          <p:cNvPr id="13" name="TextBox 12"/>
-          <p:cNvSpPr txBox="1"/>
-          <p:nvPr/>
-        </p:nvSpPr>
-        <p:spPr>
-          <a:xfrm>
-            <a:off x="8266176" y="2194560"/>
-            <a:ext cx="2999232" cy="1965960"/>
-          </a:xfrm>
-          <a:prstGeom prst="rect">
-            <a:avLst/>
-          </a:prstGeom>
-          <a:noFill/>
-        </p:spPr>
-        <p:txBody>
-          <a:bodyPr wrap="square">
-            <a:spAutoFit/>
-          </a:bodyPr>
-          <a:lstStyle/>
-          <a:p>
-            <a:pPr>
-              <a:spcBef>
-                <a:spcPts val="300"/>
-              </a:spcBef>
-              <a:defRPr b="1" sz="1050">
-                <a:solidFill>
-                  <a:srgbClr val="F8FAFC"/>
-                </a:solidFill>
-              </a:defRPr>
-            </a:pPr>
-            <a:r>
-              <a:t>• Trigger: </a:t>
-            </a:r>
-            <a:r>
-              <a:rPr b="0" sz="1000">
-                <a:solidFill>
-                  <a:srgbClr val="94A3B8"/>
-                </a:solidFill>
-              </a:rPr>
-              <a:t>High-capacity narrow-body turns at hub stations.</a:t>
-            </a:r>
-          </a:p>
-          <a:p>
-            <a:pPr>
-              <a:spcBef>
-                <a:spcPts val="300"/>
-              </a:spcBef>
-              <a:defRPr b="1" sz="1050">
-                <a:solidFill>
-                  <a:srgbClr val="F8FAFC"/>
-                </a:solidFill>
-              </a:defRPr>
-            </a:pPr>
-            <a:r>
-              <a:t>• Protocol: </a:t>
-            </a:r>
-            <a:r>
-              <a:rPr b="0" sz="1000">
-                <a:solidFill>
-                  <a:srgbClr val="94A3B8"/>
-                </a:solidFill>
-              </a:rPr>
-              <a:t>Pre-clear gate check bags in the boarding lounge 20 minutes prior to cabin door opening.</a:t>
-            </a:r>
-          </a:p>
-          <a:p>
-            <a:pPr>
-              <a:spcBef>
-                <a:spcPts val="300"/>
-              </a:spcBef>
-              <a:defRPr b="1" sz="1050">
-                <a:solidFill>
-                  <a:srgbClr val="F8FAFC"/>
-                </a:solidFill>
-              </a:defRPr>
-            </a:pPr>
-            <a:r>
-              <a:t>• Impact: </a:t>
-            </a:r>
-            <a:r>
-              <a:rPr b="0" sz="1000">
-                <a:solidFill>
-                  <a:srgbClr val="94A3B8"/>
-                </a:solidFill>
-              </a:rPr>
-              <a:t>Compresses passenger boarding duration by 8-10 minutes.</a:t>
-            </a:r>
-          </a:p>
-        </p:txBody>
-      </p:sp>
-      <p:sp>
-        <p:nvSpPr>
-          <p:cNvPr id="14" name="Rounded Rectangle 13"/>
-          <p:cNvSpPr/>
-          <p:nvPr/>
-        </p:nvSpPr>
-        <p:spPr>
-          <a:xfrm>
-            <a:off x="731520" y="4434840"/>
-            <a:ext cx="10728655" cy="1920240"/>
-          </a:xfrm>
-          <a:prstGeom prst="roundRect">
-            <a:avLst/>
-          </a:prstGeom>
-          <a:solidFill>
-            <a:srgbClr val="182132"/>
-          </a:solidFill>
-          <a:ln w="12700">
-            <a:solidFill>
-              <a:srgbClr val="2D3C55"/>
-            </a:solidFill>
-          </a:ln>
-        </p:spPr>
-        <p:style>
-          <a:lnRef idx="1">
-            <a:schemeClr val="accent1"/>
-          </a:lnRef>
-          <a:fillRef idx="3">
-            <a:schemeClr val="accent1"/>
-          </a:fillRef>
-          <a:effectRef idx="2">
-            <a:schemeClr val="accent1"/>
-          </a:effectRef>
-          <a:fontRef idx="minor">
-            <a:schemeClr val="lt1"/>
-          </a:fontRef>
-        </p:style>
-        <p:txBody>
-          <a:bodyPr rtlCol="0" anchor="ctr"/>
-          <a:lstStyle/>
-          <a:p>
-            <a:pPr algn="ctr"/>
-          </a:p>
-        </p:txBody>
-      </p:sp>
-      <p:sp>
-        <p:nvSpPr>
-          <p:cNvPr id="15" name="TextBox 14"/>
-          <p:cNvSpPr txBox="1"/>
-          <p:nvPr/>
-        </p:nvSpPr>
-        <p:spPr>
-          <a:xfrm>
-            <a:off x="960120" y="4617720"/>
-            <a:ext cx="10271455" cy="365760"/>
-          </a:xfrm>
-          <a:prstGeom prst="rect">
-            <a:avLst/>
-          </a:prstGeom>
-          <a:noFill/>
-        </p:spPr>
-        <p:txBody>
-          <a:bodyPr wrap="square" lIns="0" tIns="0" rIns="0" bIns="0">
-            <a:spAutoFit/>
-          </a:bodyPr>
-          <a:lstStyle/>
-          <a:p>
-            <a:pPr>
-              <a:defRPr sz="1400" b="1">
-                <a:solidFill>
-                  <a:srgbClr val="A855F7"/>
-                </a:solidFill>
-              </a:defRPr>
-            </a:pPr>
-            <a:r>
-              <a:t>Future Optimization Roadmap</a:t>
-            </a:r>
-          </a:p>
-        </p:txBody>
-      </p:sp>
-      <p:sp>
-        <p:nvSpPr>
-          <p:cNvPr id="16" name="TextBox 15"/>
-          <p:cNvSpPr txBox="1"/>
-          <p:nvPr/>
-        </p:nvSpPr>
-        <p:spPr>
-          <a:xfrm>
-            <a:off x="960120" y="5029200"/>
-            <a:ext cx="10271455" cy="1234440"/>
-          </a:xfrm>
-          <a:prstGeom prst="rect">
-            <a:avLst/>
-          </a:prstGeom>
-          <a:noFill/>
-        </p:spPr>
-        <p:txBody>
-          <a:bodyPr wrap="square">
-            <a:spAutoFit/>
-          </a:bodyPr>
-          <a:lstStyle/>
-          <a:p>
-            <a:pPr>
-              <a:spcBef>
-                <a:spcPts val="300"/>
-              </a:spcBef>
-              <a:defRPr b="1" sz="1100">
-                <a:solidFill>
-                  <a:srgbClr val="F8FAFC"/>
-                </a:solidFill>
-              </a:defRPr>
-            </a:pPr>
-            <a:r>
-              <a:t>•  Phase 1: Foundation (Completed): </a:t>
-            </a:r>
-            <a:r>
-              <a:rPr b="0" sz="1050">
-                <a:solidFill>
-                  <a:srgbClr val="94A3B8"/>
-                </a:solidFill>
-              </a:rPr>
-              <a:t>Historical ingestion (441k flights), SQLite B-Tree LAG() sequencing, class-balanced Random Forest (81.9% PR-AUC).</a:t>
-            </a:r>
-          </a:p>
-          <a:p>
-            <a:pPr>
-              <a:spcBef>
-                <a:spcPts val="300"/>
-              </a:spcBef>
-              <a:defRPr b="1" sz="1100">
-                <a:solidFill>
-                  <a:srgbClr val="F8FAFC"/>
-                </a:solidFill>
-              </a:defRPr>
-            </a:pPr>
-            <a:r>
-              <a:t>•  Phase 2: Streaming Telemetry Integration: </a:t>
-            </a:r>
-            <a:r>
-              <a:rPr b="0" sz="1050">
-                <a:solidFill>
-                  <a:srgbClr val="94A3B8"/>
-                </a:solidFill>
-              </a:rPr>
-              <a:t>Ingest live ACARS / ADS-B GPS position feeds to recalculate turnaround buffer risk dynamically every 60 seconds airborne.</a:t>
-            </a:r>
-          </a:p>
-          <a:p>
-            <a:pPr>
-              <a:spcBef>
-                <a:spcPts val="300"/>
-              </a:spcBef>
-              <a:defRPr b="1" sz="1100">
-                <a:solidFill>
-                  <a:srgbClr val="F8FAFC"/>
-                </a:solidFill>
-              </a:defRPr>
-            </a:pPr>
-            <a:r>
-              <a:t>•  Phase 3: Mathematical Optimization (MILP): </a:t>
-            </a:r>
-            <a:r>
-              <a:rPr b="0" sz="1050">
-                <a:solidFill>
-                  <a:srgbClr val="94A3B8"/>
-                </a:solidFill>
-              </a:rPr>
-              <a:t>Deploy a Mixed-Integer Linear Programming solver to automatically optimize gate allocations and ground crew rosters across entire hub complexes.</a:t>
+              <a:t>Pre-stages boarding groups and cabin baggage tagging 20 minutes prior to door opening (saves 8-10 min).</a:t>
             </a:r>
           </a:p>
         </p:txBody>

</xml_diff>